<commit_message>
feat(ui): Apply Clean Enterprise design to ComunicacionesView, ArchivosView, SettingsModal
</commit_message>
<xml_diff>
--- a/PAIC Redes.pptx
+++ b/PAIC Redes.pptx
@@ -5,19 +5,18 @@
     <p:sldMasterId id="2147483648" r:id="rId1"/>
   </p:sldMasterIdLst>
   <p:sldIdLst>
-    <p:sldId id="256" r:id="rId2"/>
-    <p:sldId id="257" r:id="rId3"/>
-    <p:sldId id="258" r:id="rId4"/>
-    <p:sldId id="259" r:id="rId5"/>
-    <p:sldId id="260" r:id="rId6"/>
-    <p:sldId id="261" r:id="rId7"/>
-    <p:sldId id="262" r:id="rId8"/>
-    <p:sldId id="263" r:id="rId9"/>
-    <p:sldId id="264" r:id="rId10"/>
-    <p:sldId id="265" r:id="rId11"/>
-    <p:sldId id="266" r:id="rId12"/>
-    <p:sldId id="267" r:id="rId13"/>
-    <p:sldId id="268" r:id="rId14"/>
+    <p:sldId id="257" r:id="rId2"/>
+    <p:sldId id="258" r:id="rId3"/>
+    <p:sldId id="259" r:id="rId4"/>
+    <p:sldId id="260" r:id="rId5"/>
+    <p:sldId id="261" r:id="rId6"/>
+    <p:sldId id="262" r:id="rId7"/>
+    <p:sldId id="263" r:id="rId8"/>
+    <p:sldId id="264" r:id="rId9"/>
+    <p:sldId id="265" r:id="rId10"/>
+    <p:sldId id="266" r:id="rId11"/>
+    <p:sldId id="267" r:id="rId12"/>
+    <p:sldId id="268" r:id="rId13"/>
   </p:sldIdLst>
   <p:sldSz cx="12192000" cy="6858000"/>
   <p:notesSz cx="6858000" cy="9144000"/>
@@ -124,6 +123,27 @@
 </p:presentation>
 </file>
 
+<file path=ppt/changesInfos/changesInfo1.xml><?xml version="1.0" encoding="utf-8"?>
+<pc:chgInfo xmlns:a="http://schemas.openxmlformats.org/drawingml/2006/main" xmlns:r="http://schemas.openxmlformats.org/officeDocument/2006/relationships" xmlns:ac="http://schemas.microsoft.com/office/drawing/2013/main/command" xmlns:pc="http://schemas.microsoft.com/office/powerpoint/2013/main/command">
+  <pc:docChgLst>
+    <pc:chgData name="Héctor Mauricio Pineda" userId="c7e756c87e1902e4" providerId="LiveId" clId="{BC815025-23A5-4E5B-B84B-7A9DC51BF681}"/>
+    <pc:docChg chg="delSld">
+      <pc:chgData name="Héctor Mauricio Pineda" userId="c7e756c87e1902e4" providerId="LiveId" clId="{BC815025-23A5-4E5B-B84B-7A9DC51BF681}" dt="2026-09-28T16:04:30.913" v="0" actId="2696"/>
+      <pc:docMkLst>
+        <pc:docMk/>
+      </pc:docMkLst>
+      <pc:sldChg chg="del">
+        <pc:chgData name="Héctor Mauricio Pineda" userId="c7e756c87e1902e4" providerId="LiveId" clId="{BC815025-23A5-4E5B-B84B-7A9DC51BF681}" dt="2026-09-28T16:04:30.913" v="0" actId="2696"/>
+        <pc:sldMkLst>
+          <pc:docMk/>
+          <pc:sldMk cId="2791466258" sldId="256"/>
+        </pc:sldMkLst>
+      </pc:sldChg>
+    </pc:docChg>
+  </pc:docChgLst>
+</pc:chgInfo>
+</file>
+
 <file path=ppt/slideLayouts/slideLayout1.xml><?xml version="1.0" encoding="utf-8"?>
 <p:sldLayout xmlns:a="http://schemas.openxmlformats.org/drawingml/2006/main" xmlns:r="http://schemas.openxmlformats.org/officeDocument/2006/relationships" xmlns:p="http://schemas.openxmlformats.org/presentationml/2006/main" type="title" preserve="1">
   <p:cSld name="Diapositiva de título">
@@ -273,7 +293,7 @@
           <a:p>
             <a:fld id="{BA8FD21E-C980-46DC-9E43-6C64DF0F21CF}" type="datetimeFigureOut">
               <a:rPr lang="es-CO" smtClean="0"/>
-              <a:t>18/07/2026</a:t>
+              <a:t>28/09/2026</a:t>
             </a:fld>
             <a:endParaRPr lang="es-CO"/>
           </a:p>
@@ -473,7 +493,7 @@
           <a:p>
             <a:fld id="{BA8FD21E-C980-46DC-9E43-6C64DF0F21CF}" type="datetimeFigureOut">
               <a:rPr lang="es-CO" smtClean="0"/>
-              <a:t>18/07/2026</a:t>
+              <a:t>28/09/2026</a:t>
             </a:fld>
             <a:endParaRPr lang="es-CO"/>
           </a:p>
@@ -683,7 +703,7 @@
           <a:p>
             <a:fld id="{BA8FD21E-C980-46DC-9E43-6C64DF0F21CF}" type="datetimeFigureOut">
               <a:rPr lang="es-CO" smtClean="0"/>
-              <a:t>18/07/2026</a:t>
+              <a:t>28/09/2026</a:t>
             </a:fld>
             <a:endParaRPr lang="es-CO"/>
           </a:p>
@@ -883,7 +903,7 @@
           <a:p>
             <a:fld id="{BA8FD21E-C980-46DC-9E43-6C64DF0F21CF}" type="datetimeFigureOut">
               <a:rPr lang="es-CO" smtClean="0"/>
-              <a:t>18/07/2026</a:t>
+              <a:t>28/09/2026</a:t>
             </a:fld>
             <a:endParaRPr lang="es-CO"/>
           </a:p>
@@ -1159,7 +1179,7 @@
           <a:p>
             <a:fld id="{BA8FD21E-C980-46DC-9E43-6C64DF0F21CF}" type="datetimeFigureOut">
               <a:rPr lang="es-CO" smtClean="0"/>
-              <a:t>18/07/2026</a:t>
+              <a:t>28/09/2026</a:t>
             </a:fld>
             <a:endParaRPr lang="es-CO"/>
           </a:p>
@@ -1427,7 +1447,7 @@
           <a:p>
             <a:fld id="{BA8FD21E-C980-46DC-9E43-6C64DF0F21CF}" type="datetimeFigureOut">
               <a:rPr lang="es-CO" smtClean="0"/>
-              <a:t>18/07/2026</a:t>
+              <a:t>28/09/2026</a:t>
             </a:fld>
             <a:endParaRPr lang="es-CO"/>
           </a:p>
@@ -1842,7 +1862,7 @@
           <a:p>
             <a:fld id="{BA8FD21E-C980-46DC-9E43-6C64DF0F21CF}" type="datetimeFigureOut">
               <a:rPr lang="es-CO" smtClean="0"/>
-              <a:t>18/07/2026</a:t>
+              <a:t>28/09/2026</a:t>
             </a:fld>
             <a:endParaRPr lang="es-CO"/>
           </a:p>
@@ -1984,7 +2004,7 @@
           <a:p>
             <a:fld id="{BA8FD21E-C980-46DC-9E43-6C64DF0F21CF}" type="datetimeFigureOut">
               <a:rPr lang="es-CO" smtClean="0"/>
-              <a:t>18/07/2026</a:t>
+              <a:t>28/09/2026</a:t>
             </a:fld>
             <a:endParaRPr lang="es-CO"/>
           </a:p>
@@ -2097,7 +2117,7 @@
           <a:p>
             <a:fld id="{BA8FD21E-C980-46DC-9E43-6C64DF0F21CF}" type="datetimeFigureOut">
               <a:rPr lang="es-CO" smtClean="0"/>
-              <a:t>18/07/2026</a:t>
+              <a:t>28/09/2026</a:t>
             </a:fld>
             <a:endParaRPr lang="es-CO"/>
           </a:p>
@@ -2410,7 +2430,7 @@
           <a:p>
             <a:fld id="{BA8FD21E-C980-46DC-9E43-6C64DF0F21CF}" type="datetimeFigureOut">
               <a:rPr lang="es-CO" smtClean="0"/>
-              <a:t>18/07/2026</a:t>
+              <a:t>28/09/2026</a:t>
             </a:fld>
             <a:endParaRPr lang="es-CO"/>
           </a:p>
@@ -2699,7 +2719,7 @@
           <a:p>
             <a:fld id="{BA8FD21E-C980-46DC-9E43-6C64DF0F21CF}" type="datetimeFigureOut">
               <a:rPr lang="es-CO" smtClean="0"/>
-              <a:t>18/07/2026</a:t>
+              <a:t>28/09/2026</a:t>
             </a:fld>
             <a:endParaRPr lang="es-CO"/>
           </a:p>
@@ -2942,7 +2962,7 @@
           <a:p>
             <a:fld id="{BA8FD21E-C980-46DC-9E43-6C64DF0F21CF}" type="datetimeFigureOut">
               <a:rPr lang="es-CO" smtClean="0"/>
-              <a:t>18/07/2026</a:t>
+              <a:t>28/09/2026</a:t>
             </a:fld>
             <a:endParaRPr lang="es-CO"/>
           </a:p>
@@ -3548,7 +3568,7 @@
       </p:sp>
       <p:sp>
         <p:nvSpPr>
-          <p:cNvPr id="5" name="Rectangle 11">
+          <p:cNvPr id="12" name="Rectangle 11">
             <a:extLst>
               <a:ext uri="{FF2B5EF4-FFF2-40B4-BE49-F238E27FC236}">
                 <a16:creationId xmlns:a16="http://schemas.microsoft.com/office/drawing/2014/main" id="{29FDB030-9B49-4CED-8CCD-4D99382388AC}"/>
@@ -3856,7 +3876,7 @@
           <p:cNvPr id="3" name="Imagen 2">
             <a:extLst>
               <a:ext uri="{FF2B5EF4-FFF2-40B4-BE49-F238E27FC236}">
-                <a16:creationId xmlns:a16="http://schemas.microsoft.com/office/drawing/2014/main" id="{41F08D15-8F0D-71BF-A5DA-D67E251FFD13}"/>
+                <a16:creationId xmlns:a16="http://schemas.microsoft.com/office/drawing/2014/main" id="{BDE039E2-8D9A-A968-78B0-40BC90031E73}"/>
               </a:ext>
             </a:extLst>
           </p:cNvPr>
@@ -3879,8 +3899,8 @@
         </p:blipFill>
         <p:spPr>
           <a:xfrm>
-            <a:off x="3144358" y="643467"/>
-            <a:ext cx="5903283" cy="5571065"/>
+            <a:off x="1187573" y="643467"/>
+            <a:ext cx="9816854" cy="5571065"/>
           </a:xfrm>
           <a:prstGeom prst="rect">
             <a:avLst/>
@@ -3955,10 +3975,69 @@
           </a:p>
         </p:txBody>
       </p:sp>
+      <p:sp>
+        <p:nvSpPr>
+          <p:cNvPr id="4" name="CuadroTexto 3">
+            <a:extLst>
+              <a:ext uri="{FF2B5EF4-FFF2-40B4-BE49-F238E27FC236}">
+                <a16:creationId xmlns:a16="http://schemas.microsoft.com/office/drawing/2014/main" id="{CF798E75-5B85-AFF9-5448-E23C8AD18F35}"/>
+              </a:ext>
+            </a:extLst>
+          </p:cNvPr>
+          <p:cNvSpPr txBox="1"/>
+          <p:nvPr/>
+        </p:nvSpPr>
+        <p:spPr>
+          <a:xfrm>
+            <a:off x="4678321" y="133350"/>
+            <a:ext cx="2835357" cy="379409"/>
+          </a:xfrm>
+          <a:prstGeom prst="rect">
+            <a:avLst/>
+          </a:prstGeom>
+          <a:noFill/>
+          <a:ln w="38100" cap="flat" cmpd="sng" algn="ctr">
+            <a:solidFill>
+              <a:schemeClr val="accent2"/>
+            </a:solidFill>
+            <a:prstDash val="solid"/>
+            <a:round/>
+            <a:headEnd type="none" w="med" len="med"/>
+            <a:tailEnd type="none" w="med" len="med"/>
+          </a:ln>
+        </p:spPr>
+        <p:style>
+          <a:lnRef idx="0">
+            <a:scrgbClr r="0" g="0" b="0"/>
+          </a:lnRef>
+          <a:fillRef idx="0">
+            <a:scrgbClr r="0" g="0" b="0"/>
+          </a:fillRef>
+          <a:effectRef idx="0">
+            <a:scrgbClr r="0" g="0" b="0"/>
+          </a:effectRef>
+          <a:fontRef idx="minor">
+            <a:schemeClr val="accent2"/>
+          </a:fontRef>
+        </p:style>
+        <p:txBody>
+          <a:bodyPr wrap="square" rtlCol="0">
+            <a:spAutoFit/>
+          </a:bodyPr>
+          <a:lstStyle/>
+          <a:p>
+            <a:pPr algn="ctr"/>
+            <a:r>
+              <a:rPr lang="es-CO" b="1" dirty="0"/>
+              <a:t>Panel de control</a:t>
+            </a:r>
+          </a:p>
+        </p:txBody>
+      </p:sp>
     </p:spTree>
     <p:extLst>
       <p:ext uri="{BB962C8B-B14F-4D97-AF65-F5344CB8AC3E}">
-        <p14:creationId xmlns:p14="http://schemas.microsoft.com/office/powerpoint/2010/main" val="2791466258"/>
+        <p14:creationId xmlns:p14="http://schemas.microsoft.com/office/powerpoint/2010/main" val="3376057791"/>
       </p:ext>
     </p:extLst>
   </p:cSld>
@@ -4482,7 +4561,7 @@
           <p:cNvPr id="3" name="Imagen 2">
             <a:extLst>
               <a:ext uri="{FF2B5EF4-FFF2-40B4-BE49-F238E27FC236}">
-                <a16:creationId xmlns:a16="http://schemas.microsoft.com/office/drawing/2014/main" id="{4E0CFFBE-8F93-5A2A-3593-8B1C2315A87F}"/>
+                <a16:creationId xmlns:a16="http://schemas.microsoft.com/office/drawing/2014/main" id="{D2597954-0A94-78B9-0F16-BE040D931F4D}"/>
               </a:ext>
             </a:extLst>
           </p:cNvPr>
@@ -4505,8 +4584,8 @@
         </p:blipFill>
         <p:spPr>
           <a:xfrm>
-            <a:off x="643467" y="1861396"/>
-            <a:ext cx="10905066" cy="3135206"/>
+            <a:off x="864952" y="643467"/>
+            <a:ext cx="10462095" cy="5571065"/>
           </a:xfrm>
           <a:prstGeom prst="rect">
             <a:avLst/>
@@ -4586,7 +4665,7 @@
           <p:cNvPr id="5" name="CuadroTexto 4">
             <a:extLst>
               <a:ext uri="{FF2B5EF4-FFF2-40B4-BE49-F238E27FC236}">
-                <a16:creationId xmlns:a16="http://schemas.microsoft.com/office/drawing/2014/main" id="{1AA30F0F-F6BA-0152-7664-46AB10BB2E08}"/>
+                <a16:creationId xmlns:a16="http://schemas.microsoft.com/office/drawing/2014/main" id="{4BC7D0A7-59EC-B498-288B-93FDF9D47C45}"/>
               </a:ext>
             </a:extLst>
           </p:cNvPr>
@@ -4635,7 +4714,7 @@
             <a:pPr algn="ctr"/>
             <a:r>
               <a:rPr lang="es-CO" b="1" dirty="0"/>
-              <a:t>Gestión de tareas</a:t>
+              <a:t>Configuración de PAIC</a:t>
             </a:r>
           </a:p>
         </p:txBody>
@@ -4643,7 +4722,7 @@
     </p:spTree>
     <p:extLst>
       <p:ext uri="{BB962C8B-B14F-4D97-AF65-F5344CB8AC3E}">
-        <p14:creationId xmlns:p14="http://schemas.microsoft.com/office/powerpoint/2010/main" val="4068809485"/>
+        <p14:creationId xmlns:p14="http://schemas.microsoft.com/office/powerpoint/2010/main" val="295797952"/>
       </p:ext>
     </p:extLst>
   </p:cSld>
@@ -5167,7 +5246,7 @@
           <p:cNvPr id="3" name="Imagen 2">
             <a:extLst>
               <a:ext uri="{FF2B5EF4-FFF2-40B4-BE49-F238E27FC236}">
-                <a16:creationId xmlns:a16="http://schemas.microsoft.com/office/drawing/2014/main" id="{D2597954-0A94-78B9-0F16-BE040D931F4D}"/>
+                <a16:creationId xmlns:a16="http://schemas.microsoft.com/office/drawing/2014/main" id="{72D077F4-8A7E-5E69-C37C-3787184E875F}"/>
               </a:ext>
             </a:extLst>
           </p:cNvPr>
@@ -5190,8 +5269,8 @@
         </p:blipFill>
         <p:spPr>
           <a:xfrm>
-            <a:off x="864952" y="643467"/>
-            <a:ext cx="10462095" cy="5571065"/>
+            <a:off x="3777044" y="643467"/>
+            <a:ext cx="4637911" cy="5571065"/>
           </a:xfrm>
           <a:prstGeom prst="rect">
             <a:avLst/>
@@ -5271,7 +5350,7 @@
           <p:cNvPr id="5" name="CuadroTexto 4">
             <a:extLst>
               <a:ext uri="{FF2B5EF4-FFF2-40B4-BE49-F238E27FC236}">
-                <a16:creationId xmlns:a16="http://schemas.microsoft.com/office/drawing/2014/main" id="{4BC7D0A7-59EC-B498-288B-93FDF9D47C45}"/>
+                <a16:creationId xmlns:a16="http://schemas.microsoft.com/office/drawing/2014/main" id="{6210E176-D124-6EFB-528C-295E72F6762A}"/>
               </a:ext>
             </a:extLst>
           </p:cNvPr>
@@ -5320,7 +5399,7 @@
             <a:pPr algn="ctr"/>
             <a:r>
               <a:rPr lang="es-CO" b="1" dirty="0"/>
-              <a:t>Configuración de PAIC</a:t>
+              <a:t>Soporte PAIC</a:t>
             </a:r>
           </a:p>
         </p:txBody>
@@ -5328,7 +5407,7 @@
     </p:spTree>
     <p:extLst>
       <p:ext uri="{BB962C8B-B14F-4D97-AF65-F5344CB8AC3E}">
-        <p14:creationId xmlns:p14="http://schemas.microsoft.com/office/powerpoint/2010/main" val="295797952"/>
+        <p14:creationId xmlns:p14="http://schemas.microsoft.com/office/powerpoint/2010/main" val="2533460273"/>
       </p:ext>
     </p:extLst>
   </p:cSld>
@@ -5365,7 +5444,7 @@
       </p:grpSpPr>
       <p:sp>
         <p:nvSpPr>
-          <p:cNvPr id="8" name="Rectangle 7">
+          <p:cNvPr id="10" name="Rectangle 9">
             <a:extLst>
               <a:ext uri="{FF2B5EF4-FFF2-40B4-BE49-F238E27FC236}">
                 <a16:creationId xmlns:a16="http://schemas.microsoft.com/office/drawing/2014/main" id="{F3060C83-F051-4F0E-ABAD-AA0DFC48B218}"/>
@@ -5428,7 +5507,7 @@
       </p:sp>
       <p:sp>
         <p:nvSpPr>
-          <p:cNvPr id="10" name="Freeform: Shape 9">
+          <p:cNvPr id="12" name="Freeform: Shape 11">
             <a:extLst>
               <a:ext uri="{FF2B5EF4-FFF2-40B4-BE49-F238E27FC236}">
                 <a16:creationId xmlns:a16="http://schemas.microsoft.com/office/drawing/2014/main" id="{83C98ABE-055B-441F-B07E-44F97F083C39}"/>
@@ -5544,7 +5623,7 @@
       </p:sp>
       <p:sp>
         <p:nvSpPr>
-          <p:cNvPr id="12" name="Rectangle 11">
+          <p:cNvPr id="14" name="Rectangle 13">
             <a:extLst>
               <a:ext uri="{FF2B5EF4-FFF2-40B4-BE49-F238E27FC236}">
                 <a16:creationId xmlns:a16="http://schemas.microsoft.com/office/drawing/2014/main" id="{29FDB030-9B49-4CED-8CCD-4D99382388AC}"/>
@@ -5609,7 +5688,7 @@
       </p:sp>
       <p:sp>
         <p:nvSpPr>
-          <p:cNvPr id="14" name="Rectangle 13">
+          <p:cNvPr id="16" name="Rectangle 15">
             <a:extLst>
               <a:ext uri="{FF2B5EF4-FFF2-40B4-BE49-F238E27FC236}">
                 <a16:creationId xmlns:a16="http://schemas.microsoft.com/office/drawing/2014/main" id="{3783CA14-24A1-485C-8B30-D6A5D87987AD}"/>
@@ -5674,7 +5753,7 @@
       </p:sp>
       <p:sp>
         <p:nvSpPr>
-          <p:cNvPr id="16" name="Freeform: Shape 15">
+          <p:cNvPr id="18" name="Freeform: Shape 17">
             <a:extLst>
               <a:ext uri="{FF2B5EF4-FFF2-40B4-BE49-F238E27FC236}">
                 <a16:creationId xmlns:a16="http://schemas.microsoft.com/office/drawing/2014/main" id="{9A97C86A-04D6-40F7-AE84-31AB43E6A846}"/>
@@ -5784,7 +5863,7 @@
       </p:sp>
       <p:sp>
         <p:nvSpPr>
-          <p:cNvPr id="18" name="Isosceles Triangle 17">
+          <p:cNvPr id="20" name="Isosceles Triangle 19">
             <a:extLst>
               <a:ext uri="{FF2B5EF4-FFF2-40B4-BE49-F238E27FC236}">
                 <a16:creationId xmlns:a16="http://schemas.microsoft.com/office/drawing/2014/main" id="{FF9F2414-84E8-453E-B1F3-389FDE8192D9}"/>
@@ -5849,10 +5928,10 @@
       </p:sp>
       <p:pic>
         <p:nvPicPr>
-          <p:cNvPr id="3" name="Imagen 2">
-            <a:extLst>
-              <a:ext uri="{FF2B5EF4-FFF2-40B4-BE49-F238E27FC236}">
-                <a16:creationId xmlns:a16="http://schemas.microsoft.com/office/drawing/2014/main" id="{72D077F4-8A7E-5E69-C37C-3787184E875F}"/>
+          <p:cNvPr id="5" name="Imagen 4">
+            <a:extLst>
+              <a:ext uri="{FF2B5EF4-FFF2-40B4-BE49-F238E27FC236}">
+                <a16:creationId xmlns:a16="http://schemas.microsoft.com/office/drawing/2014/main" id="{A8517BAD-3EC3-B1FB-9E67-BB587731E724}"/>
               </a:ext>
             </a:extLst>
           </p:cNvPr>
@@ -5875,8 +5954,8 @@
         </p:blipFill>
         <p:spPr>
           <a:xfrm>
-            <a:off x="3777044" y="643467"/>
-            <a:ext cx="4637911" cy="5571065"/>
+            <a:off x="643467" y="907203"/>
+            <a:ext cx="10905066" cy="5043592"/>
           </a:xfrm>
           <a:prstGeom prst="rect">
             <a:avLst/>
@@ -5888,7 +5967,7 @@
       </p:pic>
       <p:sp>
         <p:nvSpPr>
-          <p:cNvPr id="20" name="Isosceles Triangle 19">
+          <p:cNvPr id="22" name="Isosceles Triangle 21">
             <a:extLst>
               <a:ext uri="{FF2B5EF4-FFF2-40B4-BE49-F238E27FC236}">
                 <a16:creationId xmlns:a16="http://schemas.microsoft.com/office/drawing/2014/main" id="{3ECA69A1-7536-43AC-85EF-C7106179F5ED}"/>
@@ -5953,10 +6032,10 @@
       </p:sp>
       <p:sp>
         <p:nvSpPr>
-          <p:cNvPr id="5" name="CuadroTexto 4">
-            <a:extLst>
-              <a:ext uri="{FF2B5EF4-FFF2-40B4-BE49-F238E27FC236}">
-                <a16:creationId xmlns:a16="http://schemas.microsoft.com/office/drawing/2014/main" id="{6210E176-D124-6EFB-528C-295E72F6762A}"/>
+          <p:cNvPr id="13" name="CuadroTexto 12">
+            <a:extLst>
+              <a:ext uri="{FF2B5EF4-FFF2-40B4-BE49-F238E27FC236}">
+                <a16:creationId xmlns:a16="http://schemas.microsoft.com/office/drawing/2014/main" id="{A4D04D02-52A3-897F-783B-700822F77E93}"/>
               </a:ext>
             </a:extLst>
           </p:cNvPr>
@@ -6005,15 +6084,111 @@
             <a:pPr algn="ctr"/>
             <a:r>
               <a:rPr lang="es-CO" b="1" dirty="0"/>
-              <a:t>Soporte PAIC</a:t>
+              <a:t>Aprende PAIC</a:t>
             </a:r>
           </a:p>
         </p:txBody>
       </p:sp>
+      <p:sp>
+        <p:nvSpPr>
+          <p:cNvPr id="6" name="CuadroTexto 5">
+            <a:extLst>
+              <a:ext uri="{FF2B5EF4-FFF2-40B4-BE49-F238E27FC236}">
+                <a16:creationId xmlns:a16="http://schemas.microsoft.com/office/drawing/2014/main" id="{6D4076C0-25EF-7C0A-D718-48B2EC777116}"/>
+              </a:ext>
+            </a:extLst>
+          </p:cNvPr>
+          <p:cNvSpPr txBox="1"/>
+          <p:nvPr/>
+        </p:nvSpPr>
+        <p:spPr>
+          <a:xfrm>
+            <a:off x="6915150" y="148117"/>
+            <a:ext cx="4267200" cy="646331"/>
+          </a:xfrm>
+          <a:prstGeom prst="rect">
+            <a:avLst/>
+          </a:prstGeom>
+          <a:solidFill>
+            <a:schemeClr val="accent2"/>
+          </a:solidFill>
+          <a:ln>
+            <a:noFill/>
+          </a:ln>
+        </p:spPr>
+        <p:style>
+          <a:lnRef idx="0">
+            <a:scrgbClr r="0" g="0" b="0"/>
+          </a:lnRef>
+          <a:fillRef idx="0">
+            <a:scrgbClr r="0" g="0" b="0"/>
+          </a:fillRef>
+          <a:effectRef idx="0">
+            <a:scrgbClr r="0" g="0" b="0"/>
+          </a:effectRef>
+          <a:fontRef idx="minor">
+            <a:schemeClr val="lt1"/>
+          </a:fontRef>
+        </p:style>
+        <p:txBody>
+          <a:bodyPr wrap="square" rtlCol="0">
+            <a:spAutoFit/>
+          </a:bodyPr>
+          <a:lstStyle/>
+          <a:p>
+            <a:pPr algn="ctr"/>
+            <a:r>
+              <a:rPr lang="es-CO" b="1" dirty="0"/>
+              <a:t>Ponte los audífonos y toma el tour guiado, te sorprenderá!</a:t>
+            </a:r>
+          </a:p>
+        </p:txBody>
+      </p:sp>
+      <p:cxnSp>
+        <p:nvCxnSpPr>
+          <p:cNvPr id="8" name="Conector recto de flecha 7">
+            <a:extLst>
+              <a:ext uri="{FF2B5EF4-FFF2-40B4-BE49-F238E27FC236}">
+                <a16:creationId xmlns:a16="http://schemas.microsoft.com/office/drawing/2014/main" id="{E9E99C5F-2D7A-075A-FC52-81DAC6527946}"/>
+              </a:ext>
+            </a:extLst>
+          </p:cNvPr>
+          <p:cNvCxnSpPr>
+            <a:cxnSpLocks/>
+          </p:cNvCxnSpPr>
+          <p:nvPr/>
+        </p:nvCxnSpPr>
+        <p:spPr>
+          <a:xfrm>
+            <a:off x="9161294" y="761796"/>
+            <a:ext cx="563731" cy="237080"/>
+          </a:xfrm>
+          <a:prstGeom prst="straightConnector1">
+            <a:avLst/>
+          </a:prstGeom>
+          <a:ln w="38100">
+            <a:tailEnd type="triangle"/>
+          </a:ln>
+        </p:spPr>
+        <p:style>
+          <a:lnRef idx="2">
+            <a:schemeClr val="accent2"/>
+          </a:lnRef>
+          <a:fillRef idx="0">
+            <a:schemeClr val="accent2"/>
+          </a:fillRef>
+          <a:effectRef idx="1">
+            <a:schemeClr val="accent2"/>
+          </a:effectRef>
+          <a:fontRef idx="minor">
+            <a:schemeClr val="tx1"/>
+          </a:fontRef>
+        </p:style>
+      </p:cxnSp>
     </p:spTree>
     <p:extLst>
       <p:ext uri="{BB962C8B-B14F-4D97-AF65-F5344CB8AC3E}">
-        <p14:creationId xmlns:p14="http://schemas.microsoft.com/office/powerpoint/2010/main" val="2533460273"/>
+        <p14:creationId xmlns:p14="http://schemas.microsoft.com/office/powerpoint/2010/main" val="4032973602"/>
       </p:ext>
     </p:extLst>
   </p:cSld>
@@ -6023,7 +6198,7 @@
 </p:sld>
 </file>
 
-<file path=ppt/slides/slide13.xml><?xml version="1.0" encoding="utf-8"?>
+<file path=ppt/slides/slide2.xml><?xml version="1.0" encoding="utf-8"?>
 <p:sld xmlns:a="http://schemas.openxmlformats.org/drawingml/2006/main" xmlns:r="http://schemas.openxmlformats.org/officeDocument/2006/relationships" xmlns:p="http://schemas.openxmlformats.org/presentationml/2006/main">
   <p:cSld>
     <p:bg>
@@ -6050,7 +6225,7 @@
       </p:grpSpPr>
       <p:sp>
         <p:nvSpPr>
-          <p:cNvPr id="10" name="Rectangle 9">
+          <p:cNvPr id="8" name="Rectangle 7">
             <a:extLst>
               <a:ext uri="{FF2B5EF4-FFF2-40B4-BE49-F238E27FC236}">
                 <a16:creationId xmlns:a16="http://schemas.microsoft.com/office/drawing/2014/main" id="{F3060C83-F051-4F0E-ABAD-AA0DFC48B218}"/>
@@ -6113,7 +6288,7 @@
       </p:sp>
       <p:sp>
         <p:nvSpPr>
-          <p:cNvPr id="12" name="Freeform: Shape 11">
+          <p:cNvPr id="10" name="Freeform: Shape 9">
             <a:extLst>
               <a:ext uri="{FF2B5EF4-FFF2-40B4-BE49-F238E27FC236}">
                 <a16:creationId xmlns:a16="http://schemas.microsoft.com/office/drawing/2014/main" id="{83C98ABE-055B-441F-B07E-44F97F083C39}"/>
@@ -6229,7 +6404,7 @@
       </p:sp>
       <p:sp>
         <p:nvSpPr>
-          <p:cNvPr id="14" name="Rectangle 13">
+          <p:cNvPr id="12" name="Rectangle 11">
             <a:extLst>
               <a:ext uri="{FF2B5EF4-FFF2-40B4-BE49-F238E27FC236}">
                 <a16:creationId xmlns:a16="http://schemas.microsoft.com/office/drawing/2014/main" id="{29FDB030-9B49-4CED-8CCD-4D99382388AC}"/>
@@ -6294,7 +6469,7 @@
       </p:sp>
       <p:sp>
         <p:nvSpPr>
-          <p:cNvPr id="16" name="Rectangle 15">
+          <p:cNvPr id="14" name="Rectangle 13">
             <a:extLst>
               <a:ext uri="{FF2B5EF4-FFF2-40B4-BE49-F238E27FC236}">
                 <a16:creationId xmlns:a16="http://schemas.microsoft.com/office/drawing/2014/main" id="{3783CA14-24A1-485C-8B30-D6A5D87987AD}"/>
@@ -6359,7 +6534,7 @@
       </p:sp>
       <p:sp>
         <p:nvSpPr>
-          <p:cNvPr id="18" name="Freeform: Shape 17">
+          <p:cNvPr id="16" name="Freeform: Shape 15">
             <a:extLst>
               <a:ext uri="{FF2B5EF4-FFF2-40B4-BE49-F238E27FC236}">
                 <a16:creationId xmlns:a16="http://schemas.microsoft.com/office/drawing/2014/main" id="{9A97C86A-04D6-40F7-AE84-31AB43E6A846}"/>
@@ -6469,7 +6644,7 @@
       </p:sp>
       <p:sp>
         <p:nvSpPr>
-          <p:cNvPr id="20" name="Isosceles Triangle 19">
+          <p:cNvPr id="18" name="Isosceles Triangle 17">
             <a:extLst>
               <a:ext uri="{FF2B5EF4-FFF2-40B4-BE49-F238E27FC236}">
                 <a16:creationId xmlns:a16="http://schemas.microsoft.com/office/drawing/2014/main" id="{FF9F2414-84E8-453E-B1F3-389FDE8192D9}"/>
@@ -6534,10 +6709,10 @@
       </p:sp>
       <p:pic>
         <p:nvPicPr>
-          <p:cNvPr id="5" name="Imagen 4">
-            <a:extLst>
-              <a:ext uri="{FF2B5EF4-FFF2-40B4-BE49-F238E27FC236}">
-                <a16:creationId xmlns:a16="http://schemas.microsoft.com/office/drawing/2014/main" id="{A8517BAD-3EC3-B1FB-9E67-BB587731E724}"/>
+          <p:cNvPr id="3" name="Imagen 2">
+            <a:extLst>
+              <a:ext uri="{FF2B5EF4-FFF2-40B4-BE49-F238E27FC236}">
+                <a16:creationId xmlns:a16="http://schemas.microsoft.com/office/drawing/2014/main" id="{D4DC2637-03D8-4333-9C22-7F14B6F6C0EE}"/>
               </a:ext>
             </a:extLst>
           </p:cNvPr>
@@ -6560,8 +6735,8 @@
         </p:blipFill>
         <p:spPr>
           <a:xfrm>
-            <a:off x="643467" y="907203"/>
-            <a:ext cx="10905066" cy="5043592"/>
+            <a:off x="1209100" y="643467"/>
+            <a:ext cx="9773799" cy="5571065"/>
           </a:xfrm>
           <a:prstGeom prst="rect">
             <a:avLst/>
@@ -6573,7 +6748,7 @@
       </p:pic>
       <p:sp>
         <p:nvSpPr>
-          <p:cNvPr id="22" name="Isosceles Triangle 21">
+          <p:cNvPr id="20" name="Isosceles Triangle 19">
             <a:extLst>
               <a:ext uri="{FF2B5EF4-FFF2-40B4-BE49-F238E27FC236}">
                 <a16:creationId xmlns:a16="http://schemas.microsoft.com/office/drawing/2014/main" id="{3ECA69A1-7536-43AC-85EF-C7106179F5ED}"/>
@@ -6638,10 +6813,10 @@
       </p:sp>
       <p:sp>
         <p:nvSpPr>
-          <p:cNvPr id="13" name="CuadroTexto 12">
-            <a:extLst>
-              <a:ext uri="{FF2B5EF4-FFF2-40B4-BE49-F238E27FC236}">
-                <a16:creationId xmlns:a16="http://schemas.microsoft.com/office/drawing/2014/main" id="{A4D04D02-52A3-897F-783B-700822F77E93}"/>
+          <p:cNvPr id="5" name="CuadroTexto 4">
+            <a:extLst>
+              <a:ext uri="{FF2B5EF4-FFF2-40B4-BE49-F238E27FC236}">
+                <a16:creationId xmlns:a16="http://schemas.microsoft.com/office/drawing/2014/main" id="{B59B5114-929B-A9C9-0855-DA6D9F879AC3}"/>
               </a:ext>
             </a:extLst>
           </p:cNvPr>
@@ -6650,8 +6825,8 @@
         </p:nvSpPr>
         <p:spPr>
           <a:xfrm>
-            <a:off x="4468218" y="250158"/>
-            <a:ext cx="3255564" cy="369332"/>
+            <a:off x="4633119" y="143427"/>
+            <a:ext cx="2925759" cy="369332"/>
           </a:xfrm>
           <a:prstGeom prst="rect">
             <a:avLst/>
@@ -6690,111 +6865,15 @@
             <a:pPr algn="ctr"/>
             <a:r>
               <a:rPr lang="es-CO" b="1" dirty="0"/>
-              <a:t>Aprende PAIC</a:t>
+              <a:t>Gestión de copropietarios</a:t>
             </a:r>
           </a:p>
         </p:txBody>
       </p:sp>
-      <p:sp>
-        <p:nvSpPr>
-          <p:cNvPr id="6" name="CuadroTexto 5">
-            <a:extLst>
-              <a:ext uri="{FF2B5EF4-FFF2-40B4-BE49-F238E27FC236}">
-                <a16:creationId xmlns:a16="http://schemas.microsoft.com/office/drawing/2014/main" id="{6D4076C0-25EF-7C0A-D718-48B2EC777116}"/>
-              </a:ext>
-            </a:extLst>
-          </p:cNvPr>
-          <p:cNvSpPr txBox="1"/>
-          <p:nvPr/>
-        </p:nvSpPr>
-        <p:spPr>
-          <a:xfrm>
-            <a:off x="6915150" y="148117"/>
-            <a:ext cx="4267200" cy="646331"/>
-          </a:xfrm>
-          <a:prstGeom prst="rect">
-            <a:avLst/>
-          </a:prstGeom>
-          <a:solidFill>
-            <a:schemeClr val="accent2"/>
-          </a:solidFill>
-          <a:ln>
-            <a:noFill/>
-          </a:ln>
-        </p:spPr>
-        <p:style>
-          <a:lnRef idx="0">
-            <a:scrgbClr r="0" g="0" b="0"/>
-          </a:lnRef>
-          <a:fillRef idx="0">
-            <a:scrgbClr r="0" g="0" b="0"/>
-          </a:fillRef>
-          <a:effectRef idx="0">
-            <a:scrgbClr r="0" g="0" b="0"/>
-          </a:effectRef>
-          <a:fontRef idx="minor">
-            <a:schemeClr val="lt1"/>
-          </a:fontRef>
-        </p:style>
-        <p:txBody>
-          <a:bodyPr wrap="square" rtlCol="0">
-            <a:spAutoFit/>
-          </a:bodyPr>
-          <a:lstStyle/>
-          <a:p>
-            <a:pPr algn="ctr"/>
-            <a:r>
-              <a:rPr lang="es-CO" b="1" dirty="0"/>
-              <a:t>Ponte los audífonos y toma el tour guiado, te sorprenderá!</a:t>
-            </a:r>
-          </a:p>
-        </p:txBody>
-      </p:sp>
-      <p:cxnSp>
-        <p:nvCxnSpPr>
-          <p:cNvPr id="8" name="Conector recto de flecha 7">
-            <a:extLst>
-              <a:ext uri="{FF2B5EF4-FFF2-40B4-BE49-F238E27FC236}">
-                <a16:creationId xmlns:a16="http://schemas.microsoft.com/office/drawing/2014/main" id="{E9E99C5F-2D7A-075A-FC52-81DAC6527946}"/>
-              </a:ext>
-            </a:extLst>
-          </p:cNvPr>
-          <p:cNvCxnSpPr>
-            <a:cxnSpLocks/>
-          </p:cNvCxnSpPr>
-          <p:nvPr/>
-        </p:nvCxnSpPr>
-        <p:spPr>
-          <a:xfrm>
-            <a:off x="9161294" y="761796"/>
-            <a:ext cx="563731" cy="237080"/>
-          </a:xfrm>
-          <a:prstGeom prst="straightConnector1">
-            <a:avLst/>
-          </a:prstGeom>
-          <a:ln w="38100">
-            <a:tailEnd type="triangle"/>
-          </a:ln>
-        </p:spPr>
-        <p:style>
-          <a:lnRef idx="2">
-            <a:schemeClr val="accent2"/>
-          </a:lnRef>
-          <a:fillRef idx="0">
-            <a:schemeClr val="accent2"/>
-          </a:fillRef>
-          <a:effectRef idx="1">
-            <a:schemeClr val="accent2"/>
-          </a:effectRef>
-          <a:fontRef idx="minor">
-            <a:schemeClr val="tx1"/>
-          </a:fontRef>
-        </p:style>
-      </p:cxnSp>
     </p:spTree>
     <p:extLst>
       <p:ext uri="{BB962C8B-B14F-4D97-AF65-F5344CB8AC3E}">
-        <p14:creationId xmlns:p14="http://schemas.microsoft.com/office/powerpoint/2010/main" val="4032973602"/>
+        <p14:creationId xmlns:p14="http://schemas.microsoft.com/office/powerpoint/2010/main" val="3946428088"/>
       </p:ext>
     </p:extLst>
   </p:cSld>
@@ -6804,7 +6883,7 @@
 </p:sld>
 </file>
 
-<file path=ppt/slides/slide2.xml><?xml version="1.0" encoding="utf-8"?>
+<file path=ppt/slides/slide3.xml><?xml version="1.0" encoding="utf-8"?>
 <p:sld xmlns:a="http://schemas.openxmlformats.org/drawingml/2006/main" xmlns:r="http://schemas.openxmlformats.org/officeDocument/2006/relationships" xmlns:p="http://schemas.openxmlformats.org/presentationml/2006/main">
   <p:cSld>
     <p:bg>
@@ -7318,7 +7397,7 @@
           <p:cNvPr id="3" name="Imagen 2">
             <a:extLst>
               <a:ext uri="{FF2B5EF4-FFF2-40B4-BE49-F238E27FC236}">
-                <a16:creationId xmlns:a16="http://schemas.microsoft.com/office/drawing/2014/main" id="{BDE039E2-8D9A-A968-78B0-40BC90031E73}"/>
+                <a16:creationId xmlns:a16="http://schemas.microsoft.com/office/drawing/2014/main" id="{874864DE-53A7-C456-DDE5-99FA5CA3C1D2}"/>
               </a:ext>
             </a:extLst>
           </p:cNvPr>
@@ -7341,8 +7420,8 @@
         </p:blipFill>
         <p:spPr>
           <a:xfrm>
-            <a:off x="1187573" y="643467"/>
-            <a:ext cx="9816854" cy="5571065"/>
+            <a:off x="1293357" y="643467"/>
+            <a:ext cx="9605286" cy="5571065"/>
           </a:xfrm>
           <a:prstGeom prst="rect">
             <a:avLst/>
@@ -7419,10 +7498,10 @@
       </p:sp>
       <p:sp>
         <p:nvSpPr>
-          <p:cNvPr id="4" name="CuadroTexto 3">
-            <a:extLst>
-              <a:ext uri="{FF2B5EF4-FFF2-40B4-BE49-F238E27FC236}">
-                <a16:creationId xmlns:a16="http://schemas.microsoft.com/office/drawing/2014/main" id="{CF798E75-5B85-AFF9-5448-E23C8AD18F35}"/>
+          <p:cNvPr id="5" name="CuadroTexto 4">
+            <a:extLst>
+              <a:ext uri="{FF2B5EF4-FFF2-40B4-BE49-F238E27FC236}">
+                <a16:creationId xmlns:a16="http://schemas.microsoft.com/office/drawing/2014/main" id="{F6487998-4714-B39B-F78F-A11D0DB5D55E}"/>
               </a:ext>
             </a:extLst>
           </p:cNvPr>
@@ -7431,8 +7510,8 @@
         </p:nvSpPr>
         <p:spPr>
           <a:xfrm>
-            <a:off x="4678321" y="133350"/>
-            <a:ext cx="2835357" cy="379409"/>
+            <a:off x="4583511" y="243969"/>
+            <a:ext cx="3024978" cy="369332"/>
           </a:xfrm>
           <a:prstGeom prst="rect">
             <a:avLst/>
@@ -7471,7 +7550,7 @@
             <a:pPr algn="ctr"/>
             <a:r>
               <a:rPr lang="es-CO" b="1" dirty="0"/>
-              <a:t>Panel de control</a:t>
+              <a:t>Gestión de zonas comunes</a:t>
             </a:r>
           </a:p>
         </p:txBody>
@@ -7479,7 +7558,7 @@
     </p:spTree>
     <p:extLst>
       <p:ext uri="{BB962C8B-B14F-4D97-AF65-F5344CB8AC3E}">
-        <p14:creationId xmlns:p14="http://schemas.microsoft.com/office/powerpoint/2010/main" val="3376057791"/>
+        <p14:creationId xmlns:p14="http://schemas.microsoft.com/office/powerpoint/2010/main" val="3312429141"/>
       </p:ext>
     </p:extLst>
   </p:cSld>
@@ -7489,7 +7568,7 @@
 </p:sld>
 </file>
 
-<file path=ppt/slides/slide3.xml><?xml version="1.0" encoding="utf-8"?>
+<file path=ppt/slides/slide4.xml><?xml version="1.0" encoding="utf-8"?>
 <p:sld xmlns:a="http://schemas.openxmlformats.org/drawingml/2006/main" xmlns:r="http://schemas.openxmlformats.org/officeDocument/2006/relationships" xmlns:p="http://schemas.openxmlformats.org/presentationml/2006/main">
   <p:cSld>
     <p:bg>
@@ -8003,7 +8082,7 @@
           <p:cNvPr id="3" name="Imagen 2">
             <a:extLst>
               <a:ext uri="{FF2B5EF4-FFF2-40B4-BE49-F238E27FC236}">
-                <a16:creationId xmlns:a16="http://schemas.microsoft.com/office/drawing/2014/main" id="{D4DC2637-03D8-4333-9C22-7F14B6F6C0EE}"/>
+                <a16:creationId xmlns:a16="http://schemas.microsoft.com/office/drawing/2014/main" id="{1A393796-752C-FAB2-A8C7-C36F6F023FE1}"/>
               </a:ext>
             </a:extLst>
           </p:cNvPr>
@@ -8026,8 +8105,8 @@
         </p:blipFill>
         <p:spPr>
           <a:xfrm>
-            <a:off x="1209100" y="643467"/>
-            <a:ext cx="9773799" cy="5571065"/>
+            <a:off x="643467" y="879940"/>
+            <a:ext cx="10905066" cy="5098119"/>
           </a:xfrm>
           <a:prstGeom prst="rect">
             <a:avLst/>
@@ -8107,7 +8186,7 @@
           <p:cNvPr id="5" name="CuadroTexto 4">
             <a:extLst>
               <a:ext uri="{FF2B5EF4-FFF2-40B4-BE49-F238E27FC236}">
-                <a16:creationId xmlns:a16="http://schemas.microsoft.com/office/drawing/2014/main" id="{B59B5114-929B-A9C9-0855-DA6D9F879AC3}"/>
+                <a16:creationId xmlns:a16="http://schemas.microsoft.com/office/drawing/2014/main" id="{DF6A1CDB-C937-7345-A04C-48677A9A1682}"/>
               </a:ext>
             </a:extLst>
           </p:cNvPr>
@@ -8116,8 +8195,8 @@
         </p:nvSpPr>
         <p:spPr>
           <a:xfrm>
-            <a:off x="4633119" y="143427"/>
-            <a:ext cx="2925759" cy="369332"/>
+            <a:off x="4583511" y="243969"/>
+            <a:ext cx="3024978" cy="369332"/>
           </a:xfrm>
           <a:prstGeom prst="rect">
             <a:avLst/>
@@ -8156,7 +8235,7 @@
             <a:pPr algn="ctr"/>
             <a:r>
               <a:rPr lang="es-CO" b="1" dirty="0"/>
-              <a:t>Gestión de copropietarios</a:t>
+              <a:t>Gestión Comunicaciones</a:t>
             </a:r>
           </a:p>
         </p:txBody>
@@ -8164,7 +8243,7 @@
     </p:spTree>
     <p:extLst>
       <p:ext uri="{BB962C8B-B14F-4D97-AF65-F5344CB8AC3E}">
-        <p14:creationId xmlns:p14="http://schemas.microsoft.com/office/powerpoint/2010/main" val="3946428088"/>
+        <p14:creationId xmlns:p14="http://schemas.microsoft.com/office/powerpoint/2010/main" val="3754545502"/>
       </p:ext>
     </p:extLst>
   </p:cSld>
@@ -8174,7 +8253,7 @@
 </p:sld>
 </file>
 
-<file path=ppt/slides/slide4.xml><?xml version="1.0" encoding="utf-8"?>
+<file path=ppt/slides/slide5.xml><?xml version="1.0" encoding="utf-8"?>
 <p:sld xmlns:a="http://schemas.openxmlformats.org/drawingml/2006/main" xmlns:r="http://schemas.openxmlformats.org/officeDocument/2006/relationships" xmlns:p="http://schemas.openxmlformats.org/presentationml/2006/main">
   <p:cSld>
     <p:bg>
@@ -8688,7 +8767,7 @@
           <p:cNvPr id="3" name="Imagen 2">
             <a:extLst>
               <a:ext uri="{FF2B5EF4-FFF2-40B4-BE49-F238E27FC236}">
-                <a16:creationId xmlns:a16="http://schemas.microsoft.com/office/drawing/2014/main" id="{874864DE-53A7-C456-DDE5-99FA5CA3C1D2}"/>
+                <a16:creationId xmlns:a16="http://schemas.microsoft.com/office/drawing/2014/main" id="{FBD6F30F-9C76-F707-C0C7-DCB96ABAB4D4}"/>
               </a:ext>
             </a:extLst>
           </p:cNvPr>
@@ -8711,8 +8790,8 @@
         </p:blipFill>
         <p:spPr>
           <a:xfrm>
-            <a:off x="1293357" y="643467"/>
-            <a:ext cx="9605286" cy="5571065"/>
+            <a:off x="643467" y="2093129"/>
+            <a:ext cx="10905066" cy="2671740"/>
           </a:xfrm>
           <a:prstGeom prst="rect">
             <a:avLst/>
@@ -8792,7 +8871,7 @@
           <p:cNvPr id="5" name="CuadroTexto 4">
             <a:extLst>
               <a:ext uri="{FF2B5EF4-FFF2-40B4-BE49-F238E27FC236}">
-                <a16:creationId xmlns:a16="http://schemas.microsoft.com/office/drawing/2014/main" id="{F6487998-4714-B39B-F78F-A11D0DB5D55E}"/>
+                <a16:creationId xmlns:a16="http://schemas.microsoft.com/office/drawing/2014/main" id="{8CC2D895-53A7-A1A5-E175-26D476791952}"/>
               </a:ext>
             </a:extLst>
           </p:cNvPr>
@@ -8841,7 +8920,7 @@
             <a:pPr algn="ctr"/>
             <a:r>
               <a:rPr lang="es-CO" b="1" dirty="0"/>
-              <a:t>Gestión de zonas comunes</a:t>
+              <a:t>Gestión Documental</a:t>
             </a:r>
           </a:p>
         </p:txBody>
@@ -8849,7 +8928,7 @@
     </p:spTree>
     <p:extLst>
       <p:ext uri="{BB962C8B-B14F-4D97-AF65-F5344CB8AC3E}">
-        <p14:creationId xmlns:p14="http://schemas.microsoft.com/office/powerpoint/2010/main" val="3312429141"/>
+        <p14:creationId xmlns:p14="http://schemas.microsoft.com/office/powerpoint/2010/main" val="2806888958"/>
       </p:ext>
     </p:extLst>
   </p:cSld>
@@ -8859,7 +8938,7 @@
 </p:sld>
 </file>
 
-<file path=ppt/slides/slide5.xml><?xml version="1.0" encoding="utf-8"?>
+<file path=ppt/slides/slide6.xml><?xml version="1.0" encoding="utf-8"?>
 <p:sld xmlns:a="http://schemas.openxmlformats.org/drawingml/2006/main" xmlns:r="http://schemas.openxmlformats.org/officeDocument/2006/relationships" xmlns:p="http://schemas.openxmlformats.org/presentationml/2006/main">
   <p:cSld>
     <p:bg>
@@ -9373,7 +9452,7 @@
           <p:cNvPr id="3" name="Imagen 2">
             <a:extLst>
               <a:ext uri="{FF2B5EF4-FFF2-40B4-BE49-F238E27FC236}">
-                <a16:creationId xmlns:a16="http://schemas.microsoft.com/office/drawing/2014/main" id="{1A393796-752C-FAB2-A8C7-C36F6F023FE1}"/>
+                <a16:creationId xmlns:a16="http://schemas.microsoft.com/office/drawing/2014/main" id="{5F11DC1D-AE77-2E90-73CF-3177B74B07C0}"/>
               </a:ext>
             </a:extLst>
           </p:cNvPr>
@@ -9396,8 +9475,8 @@
         </p:blipFill>
         <p:spPr>
           <a:xfrm>
-            <a:off x="643467" y="879940"/>
-            <a:ext cx="10905066" cy="5098119"/>
+            <a:off x="643467" y="1111673"/>
+            <a:ext cx="10905066" cy="4634652"/>
           </a:xfrm>
           <a:prstGeom prst="rect">
             <a:avLst/>
@@ -9477,7 +9556,7 @@
           <p:cNvPr id="5" name="CuadroTexto 4">
             <a:extLst>
               <a:ext uri="{FF2B5EF4-FFF2-40B4-BE49-F238E27FC236}">
-                <a16:creationId xmlns:a16="http://schemas.microsoft.com/office/drawing/2014/main" id="{DF6A1CDB-C937-7345-A04C-48677A9A1682}"/>
+                <a16:creationId xmlns:a16="http://schemas.microsoft.com/office/drawing/2014/main" id="{8BB328EB-E593-6FF2-1561-B15D51EDBFD9}"/>
               </a:ext>
             </a:extLst>
           </p:cNvPr>
@@ -9526,7 +9605,7 @@
             <a:pPr algn="ctr"/>
             <a:r>
               <a:rPr lang="es-CO" b="1" dirty="0"/>
-              <a:t>Gestión Comunicaciones</a:t>
+              <a:t>Gestión Financiera</a:t>
             </a:r>
           </a:p>
         </p:txBody>
@@ -9534,7 +9613,7 @@
     </p:spTree>
     <p:extLst>
       <p:ext uri="{BB962C8B-B14F-4D97-AF65-F5344CB8AC3E}">
-        <p14:creationId xmlns:p14="http://schemas.microsoft.com/office/powerpoint/2010/main" val="3754545502"/>
+        <p14:creationId xmlns:p14="http://schemas.microsoft.com/office/powerpoint/2010/main" val="2729674790"/>
       </p:ext>
     </p:extLst>
   </p:cSld>
@@ -9544,7 +9623,7 @@
 </p:sld>
 </file>
 
-<file path=ppt/slides/slide6.xml><?xml version="1.0" encoding="utf-8"?>
+<file path=ppt/slides/slide7.xml><?xml version="1.0" encoding="utf-8"?>
 <p:sld xmlns:a="http://schemas.openxmlformats.org/drawingml/2006/main" xmlns:r="http://schemas.openxmlformats.org/officeDocument/2006/relationships" xmlns:p="http://schemas.openxmlformats.org/presentationml/2006/main">
   <p:cSld>
     <p:bg>
@@ -10058,7 +10137,7 @@
           <p:cNvPr id="3" name="Imagen 2">
             <a:extLst>
               <a:ext uri="{FF2B5EF4-FFF2-40B4-BE49-F238E27FC236}">
-                <a16:creationId xmlns:a16="http://schemas.microsoft.com/office/drawing/2014/main" id="{FBD6F30F-9C76-F707-C0C7-DCB96ABAB4D4}"/>
+                <a16:creationId xmlns:a16="http://schemas.microsoft.com/office/drawing/2014/main" id="{45E13F00-87E5-4E76-A3A9-5759E44E3221}"/>
               </a:ext>
             </a:extLst>
           </p:cNvPr>
@@ -10081,8 +10160,8 @@
         </p:blipFill>
         <p:spPr>
           <a:xfrm>
-            <a:off x="643467" y="2093129"/>
-            <a:ext cx="10905066" cy="2671740"/>
+            <a:off x="643467" y="1343406"/>
+            <a:ext cx="10905066" cy="4171186"/>
           </a:xfrm>
           <a:prstGeom prst="rect">
             <a:avLst/>
@@ -10162,7 +10241,7 @@
           <p:cNvPr id="5" name="CuadroTexto 4">
             <a:extLst>
               <a:ext uri="{FF2B5EF4-FFF2-40B4-BE49-F238E27FC236}">
-                <a16:creationId xmlns:a16="http://schemas.microsoft.com/office/drawing/2014/main" id="{8CC2D895-53A7-A1A5-E175-26D476791952}"/>
+                <a16:creationId xmlns:a16="http://schemas.microsoft.com/office/drawing/2014/main" id="{EEFC2C80-5DBF-C502-94E8-64294C5FC3CD}"/>
               </a:ext>
             </a:extLst>
           </p:cNvPr>
@@ -10171,8 +10250,8 @@
         </p:nvSpPr>
         <p:spPr>
           <a:xfrm>
-            <a:off x="4583511" y="243969"/>
-            <a:ext cx="3024978" cy="369332"/>
+            <a:off x="4468218" y="250158"/>
+            <a:ext cx="3255564" cy="369332"/>
           </a:xfrm>
           <a:prstGeom prst="rect">
             <a:avLst/>
@@ -10211,7 +10290,7 @@
             <a:pPr algn="ctr"/>
             <a:r>
               <a:rPr lang="es-CO" b="1" dirty="0"/>
-              <a:t>Gestión Documental</a:t>
+              <a:t>Gestión de visitas y paquetes</a:t>
             </a:r>
           </a:p>
         </p:txBody>
@@ -10219,7 +10298,7 @@
     </p:spTree>
     <p:extLst>
       <p:ext uri="{BB962C8B-B14F-4D97-AF65-F5344CB8AC3E}">
-        <p14:creationId xmlns:p14="http://schemas.microsoft.com/office/powerpoint/2010/main" val="2806888958"/>
+        <p14:creationId xmlns:p14="http://schemas.microsoft.com/office/powerpoint/2010/main" val="412010969"/>
       </p:ext>
     </p:extLst>
   </p:cSld>
@@ -10229,7 +10308,7 @@
 </p:sld>
 </file>
 
-<file path=ppt/slides/slide7.xml><?xml version="1.0" encoding="utf-8"?>
+<file path=ppt/slides/slide8.xml><?xml version="1.0" encoding="utf-8"?>
 <p:sld xmlns:a="http://schemas.openxmlformats.org/drawingml/2006/main" xmlns:r="http://schemas.openxmlformats.org/officeDocument/2006/relationships" xmlns:p="http://schemas.openxmlformats.org/presentationml/2006/main">
   <p:cSld>
     <p:bg>
@@ -10743,7 +10822,7 @@
           <p:cNvPr id="3" name="Imagen 2">
             <a:extLst>
               <a:ext uri="{FF2B5EF4-FFF2-40B4-BE49-F238E27FC236}">
-                <a16:creationId xmlns:a16="http://schemas.microsoft.com/office/drawing/2014/main" id="{5F11DC1D-AE77-2E90-73CF-3177B74B07C0}"/>
+                <a16:creationId xmlns:a16="http://schemas.microsoft.com/office/drawing/2014/main" id="{10439659-C619-B1BC-7A61-09A890FD605F}"/>
               </a:ext>
             </a:extLst>
           </p:cNvPr>
@@ -10766,8 +10845,8 @@
         </p:blipFill>
         <p:spPr>
           <a:xfrm>
-            <a:off x="643467" y="1111673"/>
-            <a:ext cx="10905066" cy="4634652"/>
+            <a:off x="643467" y="1520613"/>
+            <a:ext cx="10905066" cy="3816772"/>
           </a:xfrm>
           <a:prstGeom prst="rect">
             <a:avLst/>
@@ -10847,7 +10926,7 @@
           <p:cNvPr id="5" name="CuadroTexto 4">
             <a:extLst>
               <a:ext uri="{FF2B5EF4-FFF2-40B4-BE49-F238E27FC236}">
-                <a16:creationId xmlns:a16="http://schemas.microsoft.com/office/drawing/2014/main" id="{8BB328EB-E593-6FF2-1561-B15D51EDBFD9}"/>
+                <a16:creationId xmlns:a16="http://schemas.microsoft.com/office/drawing/2014/main" id="{A2619C58-CA1A-0779-DCDF-63269017A7D0}"/>
               </a:ext>
             </a:extLst>
           </p:cNvPr>
@@ -10856,8 +10935,8 @@
         </p:nvSpPr>
         <p:spPr>
           <a:xfrm>
-            <a:off x="4583511" y="243969"/>
-            <a:ext cx="3024978" cy="369332"/>
+            <a:off x="4468218" y="250158"/>
+            <a:ext cx="3255564" cy="369332"/>
           </a:xfrm>
           <a:prstGeom prst="rect">
             <a:avLst/>
@@ -10896,15 +10975,20 @@
             <a:pPr algn="ctr"/>
             <a:r>
               <a:rPr lang="es-CO" b="1" dirty="0"/>
-              <a:t>Gestión Financiera</a:t>
+              <a:t>Gestión de </a:t>
             </a:r>
+            <a:r>
+              <a:rPr lang="es-CO" b="1" dirty="0" err="1"/>
+              <a:t>Vecimientos</a:t>
+            </a:r>
+            <a:endParaRPr lang="es-CO" b="1" dirty="0"/>
           </a:p>
         </p:txBody>
       </p:sp>
     </p:spTree>
     <p:extLst>
       <p:ext uri="{BB962C8B-B14F-4D97-AF65-F5344CB8AC3E}">
-        <p14:creationId xmlns:p14="http://schemas.microsoft.com/office/powerpoint/2010/main" val="2729674790"/>
+        <p14:creationId xmlns:p14="http://schemas.microsoft.com/office/powerpoint/2010/main" val="843671556"/>
       </p:ext>
     </p:extLst>
   </p:cSld>
@@ -10914,7 +10998,7 @@
 </p:sld>
 </file>
 
-<file path=ppt/slides/slide8.xml><?xml version="1.0" encoding="utf-8"?>
+<file path=ppt/slides/slide9.xml><?xml version="1.0" encoding="utf-8"?>
 <p:sld xmlns:a="http://schemas.openxmlformats.org/drawingml/2006/main" xmlns:r="http://schemas.openxmlformats.org/officeDocument/2006/relationships" xmlns:p="http://schemas.openxmlformats.org/presentationml/2006/main">
   <p:cSld>
     <p:bg>
@@ -11428,7 +11512,7 @@
           <p:cNvPr id="3" name="Imagen 2">
             <a:extLst>
               <a:ext uri="{FF2B5EF4-FFF2-40B4-BE49-F238E27FC236}">
-                <a16:creationId xmlns:a16="http://schemas.microsoft.com/office/drawing/2014/main" id="{45E13F00-87E5-4E76-A3A9-5759E44E3221}"/>
+                <a16:creationId xmlns:a16="http://schemas.microsoft.com/office/drawing/2014/main" id="{4E0CFFBE-8F93-5A2A-3593-8B1C2315A87F}"/>
               </a:ext>
             </a:extLst>
           </p:cNvPr>
@@ -11451,8 +11535,8 @@
         </p:blipFill>
         <p:spPr>
           <a:xfrm>
-            <a:off x="643467" y="1343406"/>
-            <a:ext cx="10905066" cy="4171186"/>
+            <a:off x="643467" y="1861396"/>
+            <a:ext cx="10905066" cy="3135206"/>
           </a:xfrm>
           <a:prstGeom prst="rect">
             <a:avLst/>
@@ -11532,7 +11616,7 @@
           <p:cNvPr id="5" name="CuadroTexto 4">
             <a:extLst>
               <a:ext uri="{FF2B5EF4-FFF2-40B4-BE49-F238E27FC236}">
-                <a16:creationId xmlns:a16="http://schemas.microsoft.com/office/drawing/2014/main" id="{EEFC2C80-5DBF-C502-94E8-64294C5FC3CD}"/>
+                <a16:creationId xmlns:a16="http://schemas.microsoft.com/office/drawing/2014/main" id="{1AA30F0F-F6BA-0152-7664-46AB10BB2E08}"/>
               </a:ext>
             </a:extLst>
           </p:cNvPr>
@@ -11581,7 +11665,7 @@
             <a:pPr algn="ctr"/>
             <a:r>
               <a:rPr lang="es-CO" b="1" dirty="0"/>
-              <a:t>Gestión de visitas y paquetes</a:t>
+              <a:t>Gestión de tareas</a:t>
             </a:r>
           </a:p>
         </p:txBody>
@@ -11589,697 +11673,7 @@
     </p:spTree>
     <p:extLst>
       <p:ext uri="{BB962C8B-B14F-4D97-AF65-F5344CB8AC3E}">
-        <p14:creationId xmlns:p14="http://schemas.microsoft.com/office/powerpoint/2010/main" val="412010969"/>
-      </p:ext>
-    </p:extLst>
-  </p:cSld>
-  <p:clrMapOvr>
-    <a:masterClrMapping/>
-  </p:clrMapOvr>
-</p:sld>
-</file>
-
-<file path=ppt/slides/slide9.xml><?xml version="1.0" encoding="utf-8"?>
-<p:sld xmlns:a="http://schemas.openxmlformats.org/drawingml/2006/main" xmlns:r="http://schemas.openxmlformats.org/officeDocument/2006/relationships" xmlns:p="http://schemas.openxmlformats.org/presentationml/2006/main">
-  <p:cSld>
-    <p:bg>
-      <p:bgPr>
-        <a:solidFill>
-          <a:schemeClr val="bg1"/>
-        </a:solidFill>
-        <a:effectLst/>
-      </p:bgPr>
-    </p:bg>
-    <p:spTree>
-      <p:nvGrpSpPr>
-        <p:cNvPr id="1" name=""/>
-        <p:cNvGrpSpPr/>
-        <p:nvPr/>
-      </p:nvGrpSpPr>
-      <p:grpSpPr>
-        <a:xfrm>
-          <a:off x="0" y="0"/>
-          <a:ext cx="0" cy="0"/>
-          <a:chOff x="0" y="0"/>
-          <a:chExt cx="0" cy="0"/>
-        </a:xfrm>
-      </p:grpSpPr>
-      <p:sp>
-        <p:nvSpPr>
-          <p:cNvPr id="8" name="Rectangle 7">
-            <a:extLst>
-              <a:ext uri="{FF2B5EF4-FFF2-40B4-BE49-F238E27FC236}">
-                <a16:creationId xmlns:a16="http://schemas.microsoft.com/office/drawing/2014/main" id="{F3060C83-F051-4F0E-ABAD-AA0DFC48B218}"/>
-              </a:ext>
-              <a:ext uri="{C183D7F6-B498-43B3-948B-1728B52AA6E4}">
-                <adec:decorative xmlns:adec="http://schemas.microsoft.com/office/drawing/2017/decorative" val="1"/>
-              </a:ext>
-            </a:extLst>
-          </p:cNvPr>
-          <p:cNvSpPr>
-            <a:spLocks noGrp="1" noRot="1" noChangeAspect="1" noMove="1" noResize="1" noEditPoints="1" noAdjustHandles="1" noChangeArrowheads="1" noChangeShapeType="1" noTextEdit="1"/>
-          </p:cNvSpPr>
-          <p:nvPr>
-            <p:extLst>
-              <p:ext uri="{386F3935-93C4-4BCD-93E2-E3B085C9AB24}">
-                <p16:designElem xmlns:p16="http://schemas.microsoft.com/office/powerpoint/2015/main" val="1"/>
-              </p:ext>
-            </p:extLst>
-          </p:nvPr>
-        </p:nvSpPr>
-        <p:spPr>
-          <a:xfrm>
-            <a:off x="0" y="0"/>
-            <a:ext cx="12192000" cy="6858000"/>
-          </a:xfrm>
-          <a:prstGeom prst="rect">
-            <a:avLst/>
-          </a:prstGeom>
-          <a:solidFill>
-            <a:schemeClr val="bg1"/>
-          </a:solidFill>
-          <a:ln>
-            <a:noFill/>
-          </a:ln>
-        </p:spPr>
-        <p:style>
-          <a:lnRef idx="2">
-            <a:schemeClr val="accent1">
-              <a:shade val="50000"/>
-            </a:schemeClr>
-          </a:lnRef>
-          <a:fillRef idx="1">
-            <a:schemeClr val="accent1"/>
-          </a:fillRef>
-          <a:effectRef idx="0">
-            <a:schemeClr val="accent1"/>
-          </a:effectRef>
-          <a:fontRef idx="minor">
-            <a:schemeClr val="lt1"/>
-          </a:fontRef>
-        </p:style>
-        <p:txBody>
-          <a:bodyPr rtlCol="0" anchor="ctr"/>
-          <a:lstStyle/>
-          <a:p>
-            <a:pPr algn="ctr"/>
-            <a:endParaRPr lang="en-US" dirty="0"/>
-          </a:p>
-        </p:txBody>
-      </p:sp>
-      <p:sp>
-        <p:nvSpPr>
-          <p:cNvPr id="10" name="Freeform: Shape 9">
-            <a:extLst>
-              <a:ext uri="{FF2B5EF4-FFF2-40B4-BE49-F238E27FC236}">
-                <a16:creationId xmlns:a16="http://schemas.microsoft.com/office/drawing/2014/main" id="{83C98ABE-055B-441F-B07E-44F97F083C39}"/>
-              </a:ext>
-              <a:ext uri="{C183D7F6-B498-43B3-948B-1728B52AA6E4}">
-                <adec:decorative xmlns:adec="http://schemas.microsoft.com/office/drawing/2017/decorative" val="1"/>
-              </a:ext>
-            </a:extLst>
-          </p:cNvPr>
-          <p:cNvSpPr>
-            <a:spLocks noGrp="1" noRot="1" noChangeAspect="1" noMove="1" noResize="1" noEditPoints="1" noAdjustHandles="1" noChangeArrowheads="1" noChangeShapeType="1" noTextEdit="1"/>
-          </p:cNvSpPr>
-          <p:nvPr>
-            <p:extLst>
-              <p:ext uri="{386F3935-93C4-4BCD-93E2-E3B085C9AB24}">
-                <p16:designElem xmlns:p16="http://schemas.microsoft.com/office/powerpoint/2015/main" val="1"/>
-              </p:ext>
-            </p:extLst>
-          </p:nvPr>
-        </p:nvSpPr>
-        <p:spPr>
-          <a:xfrm rot="18900000" flipH="1">
-            <a:off x="-376156" y="-253670"/>
-            <a:ext cx="1827638" cy="1376989"/>
-          </a:xfrm>
-          <a:custGeom>
-            <a:avLst/>
-            <a:gdLst>
-              <a:gd name="connsiteX0" fmla="*/ 0 w 1827638"/>
-              <a:gd name="connsiteY0" fmla="*/ 987379 h 1376989"/>
-              <a:gd name="connsiteX1" fmla="*/ 987379 w 1827638"/>
-              <a:gd name="connsiteY1" fmla="*/ 0 h 1376989"/>
-              <a:gd name="connsiteX2" fmla="*/ 1827638 w 1827638"/>
-              <a:gd name="connsiteY2" fmla="*/ 840260 h 1376989"/>
-              <a:gd name="connsiteX3" fmla="*/ 1827638 w 1827638"/>
-              <a:gd name="connsiteY3" fmla="*/ 1376989 h 1376989"/>
-              <a:gd name="connsiteX4" fmla="*/ 0 w 1827638"/>
-              <a:gd name="connsiteY4" fmla="*/ 1376989 h 1376989"/>
-            </a:gdLst>
-            <a:ahLst/>
-            <a:cxnLst>
-              <a:cxn ang="0">
-                <a:pos x="connsiteX0" y="connsiteY0"/>
-              </a:cxn>
-              <a:cxn ang="0">
-                <a:pos x="connsiteX1" y="connsiteY1"/>
-              </a:cxn>
-              <a:cxn ang="0">
-                <a:pos x="connsiteX2" y="connsiteY2"/>
-              </a:cxn>
-              <a:cxn ang="0">
-                <a:pos x="connsiteX3" y="connsiteY3"/>
-              </a:cxn>
-              <a:cxn ang="0">
-                <a:pos x="connsiteX4" y="connsiteY4"/>
-              </a:cxn>
-            </a:cxnLst>
-            <a:rect l="l" t="t" r="r" b="b"/>
-            <a:pathLst>
-              <a:path w="1827638" h="1376989">
-                <a:moveTo>
-                  <a:pt x="0" y="987379"/>
-                </a:moveTo>
-                <a:lnTo>
-                  <a:pt x="987379" y="0"/>
-                </a:lnTo>
-                <a:lnTo>
-                  <a:pt x="1827638" y="840260"/>
-                </a:lnTo>
-                <a:lnTo>
-                  <a:pt x="1827638" y="1376989"/>
-                </a:lnTo>
-                <a:lnTo>
-                  <a:pt x="0" y="1376989"/>
-                </a:lnTo>
-                <a:close/>
-              </a:path>
-            </a:pathLst>
-          </a:custGeom>
-          <a:solidFill>
-            <a:schemeClr val="accent1">
-              <a:alpha val="30000"/>
-            </a:schemeClr>
-          </a:solidFill>
-          <a:ln>
-            <a:noFill/>
-          </a:ln>
-        </p:spPr>
-        <p:style>
-          <a:lnRef idx="2">
-            <a:schemeClr val="accent1">
-              <a:shade val="50000"/>
-            </a:schemeClr>
-          </a:lnRef>
-          <a:fillRef idx="1">
-            <a:schemeClr val="accent1"/>
-          </a:fillRef>
-          <a:effectRef idx="0">
-            <a:schemeClr val="accent1"/>
-          </a:effectRef>
-          <a:fontRef idx="minor">
-            <a:schemeClr val="lt1"/>
-          </a:fontRef>
-        </p:style>
-        <p:txBody>
-          <a:bodyPr rtlCol="0" anchor="ctr"/>
-          <a:lstStyle/>
-          <a:p>
-            <a:pPr algn="ctr"/>
-            <a:endParaRPr lang="en-US" dirty="0"/>
-          </a:p>
-        </p:txBody>
-      </p:sp>
-      <p:sp>
-        <p:nvSpPr>
-          <p:cNvPr id="12" name="Rectangle 11">
-            <a:extLst>
-              <a:ext uri="{FF2B5EF4-FFF2-40B4-BE49-F238E27FC236}">
-                <a16:creationId xmlns:a16="http://schemas.microsoft.com/office/drawing/2014/main" id="{29FDB030-9B49-4CED-8CCD-4D99382388AC}"/>
-              </a:ext>
-              <a:ext uri="{C183D7F6-B498-43B3-948B-1728B52AA6E4}">
-                <adec:decorative xmlns:adec="http://schemas.microsoft.com/office/drawing/2017/decorative" val="1"/>
-              </a:ext>
-            </a:extLst>
-          </p:cNvPr>
-          <p:cNvSpPr>
-            <a:spLocks noGrp="1" noRot="1" noChangeAspect="1" noMove="1" noResize="1" noEditPoints="1" noAdjustHandles="1" noChangeArrowheads="1" noChangeShapeType="1" noTextEdit="1"/>
-          </p:cNvSpPr>
-          <p:nvPr>
-            <p:extLst>
-              <p:ext uri="{386F3935-93C4-4BCD-93E2-E3B085C9AB24}">
-                <p16:designElem xmlns:p16="http://schemas.microsoft.com/office/powerpoint/2015/main" val="1"/>
-              </p:ext>
-            </p:extLst>
-          </p:nvPr>
-        </p:nvSpPr>
-        <p:spPr>
-          <a:xfrm rot="18900000" flipH="1">
-            <a:off x="891641" y="422146"/>
-            <a:ext cx="645368" cy="645368"/>
-          </a:xfrm>
-          <a:prstGeom prst="rect">
-            <a:avLst/>
-          </a:prstGeom>
-          <a:solidFill>
-            <a:schemeClr val="accent1">
-              <a:alpha val="30000"/>
-            </a:schemeClr>
-          </a:solidFill>
-          <a:ln>
-            <a:noFill/>
-          </a:ln>
-        </p:spPr>
-        <p:style>
-          <a:lnRef idx="2">
-            <a:schemeClr val="accent1">
-              <a:shade val="50000"/>
-            </a:schemeClr>
-          </a:lnRef>
-          <a:fillRef idx="1">
-            <a:schemeClr val="accent1"/>
-          </a:fillRef>
-          <a:effectRef idx="0">
-            <a:schemeClr val="accent1"/>
-          </a:effectRef>
-          <a:fontRef idx="minor">
-            <a:schemeClr val="lt1"/>
-          </a:fontRef>
-        </p:style>
-        <p:txBody>
-          <a:bodyPr rtlCol="0" anchor="ctr"/>
-          <a:lstStyle/>
-          <a:p>
-            <a:pPr algn="ctr"/>
-            <a:endParaRPr lang="en-US"/>
-          </a:p>
-        </p:txBody>
-      </p:sp>
-      <p:sp>
-        <p:nvSpPr>
-          <p:cNvPr id="14" name="Rectangle 13">
-            <a:extLst>
-              <a:ext uri="{FF2B5EF4-FFF2-40B4-BE49-F238E27FC236}">
-                <a16:creationId xmlns:a16="http://schemas.microsoft.com/office/drawing/2014/main" id="{3783CA14-24A1-485C-8B30-D6A5D87987AD}"/>
-              </a:ext>
-              <a:ext uri="{C183D7F6-B498-43B3-948B-1728B52AA6E4}">
-                <adec:decorative xmlns:adec="http://schemas.microsoft.com/office/drawing/2017/decorative" val="1"/>
-              </a:ext>
-            </a:extLst>
-          </p:cNvPr>
-          <p:cNvSpPr>
-            <a:spLocks noGrp="1" noRot="1" noChangeAspect="1" noMove="1" noResize="1" noEditPoints="1" noAdjustHandles="1" noChangeArrowheads="1" noChangeShapeType="1" noTextEdit="1"/>
-          </p:cNvSpPr>
-          <p:nvPr>
-            <p:extLst>
-              <p:ext uri="{386F3935-93C4-4BCD-93E2-E3B085C9AB24}">
-                <p16:designElem xmlns:p16="http://schemas.microsoft.com/office/powerpoint/2015/main" val="1"/>
-              </p:ext>
-            </p:extLst>
-          </p:nvPr>
-        </p:nvSpPr>
-        <p:spPr>
-          <a:xfrm rot="18900000" flipH="1">
-            <a:off x="10043482" y="655140"/>
-            <a:ext cx="687472" cy="687472"/>
-          </a:xfrm>
-          <a:prstGeom prst="rect">
-            <a:avLst/>
-          </a:prstGeom>
-          <a:solidFill>
-            <a:schemeClr val="accent4">
-              <a:alpha val="30000"/>
-            </a:schemeClr>
-          </a:solidFill>
-          <a:ln>
-            <a:noFill/>
-          </a:ln>
-        </p:spPr>
-        <p:style>
-          <a:lnRef idx="2">
-            <a:schemeClr val="accent1">
-              <a:shade val="50000"/>
-            </a:schemeClr>
-          </a:lnRef>
-          <a:fillRef idx="1">
-            <a:schemeClr val="accent1"/>
-          </a:fillRef>
-          <a:effectRef idx="0">
-            <a:schemeClr val="accent1"/>
-          </a:effectRef>
-          <a:fontRef idx="minor">
-            <a:schemeClr val="lt1"/>
-          </a:fontRef>
-        </p:style>
-        <p:txBody>
-          <a:bodyPr rtlCol="0" anchor="ctr"/>
-          <a:lstStyle/>
-          <a:p>
-            <a:pPr algn="ctr"/>
-            <a:endParaRPr lang="en-US"/>
-          </a:p>
-        </p:txBody>
-      </p:sp>
-      <p:sp>
-        <p:nvSpPr>
-          <p:cNvPr id="16" name="Freeform: Shape 15">
-            <a:extLst>
-              <a:ext uri="{FF2B5EF4-FFF2-40B4-BE49-F238E27FC236}">
-                <a16:creationId xmlns:a16="http://schemas.microsoft.com/office/drawing/2014/main" id="{9A97C86A-04D6-40F7-AE84-31AB43E6A846}"/>
-              </a:ext>
-              <a:ext uri="{C183D7F6-B498-43B3-948B-1728B52AA6E4}">
-                <adec:decorative xmlns:adec="http://schemas.microsoft.com/office/drawing/2017/decorative" val="1"/>
-              </a:ext>
-            </a:extLst>
-          </p:cNvPr>
-          <p:cNvSpPr>
-            <a:spLocks noGrp="1" noRot="1" noChangeAspect="1" noMove="1" noResize="1" noEditPoints="1" noAdjustHandles="1" noChangeArrowheads="1" noChangeShapeType="1" noTextEdit="1"/>
-          </p:cNvSpPr>
-          <p:nvPr>
-            <p:extLst>
-              <p:ext uri="{386F3935-93C4-4BCD-93E2-E3B085C9AB24}">
-                <p16:designElem xmlns:p16="http://schemas.microsoft.com/office/powerpoint/2015/main" val="1"/>
-              </p:ext>
-            </p:extLst>
-          </p:nvPr>
-        </p:nvSpPr>
-        <p:spPr>
-          <a:xfrm rot="10800000" flipH="1">
-            <a:off x="9356643" y="0"/>
-            <a:ext cx="2835357" cy="1480837"/>
-          </a:xfrm>
-          <a:custGeom>
-            <a:avLst/>
-            <a:gdLst>
-              <a:gd name="connsiteX0" fmla="*/ 2835357 w 2835357"/>
-              <a:gd name="connsiteY0" fmla="*/ 1480837 h 1480837"/>
-              <a:gd name="connsiteX1" fmla="*/ 0 w 2835357"/>
-              <a:gd name="connsiteY1" fmla="*/ 1480837 h 1480837"/>
-              <a:gd name="connsiteX2" fmla="*/ 1552727 w 2835357"/>
-              <a:gd name="connsiteY2" fmla="*/ 0 h 1480837"/>
-              <a:gd name="connsiteX3" fmla="*/ 2835357 w 2835357"/>
-              <a:gd name="connsiteY3" fmla="*/ 1223245 h 1480837"/>
-            </a:gdLst>
-            <a:ahLst/>
-            <a:cxnLst>
-              <a:cxn ang="0">
-                <a:pos x="connsiteX0" y="connsiteY0"/>
-              </a:cxn>
-              <a:cxn ang="0">
-                <a:pos x="connsiteX1" y="connsiteY1"/>
-              </a:cxn>
-              <a:cxn ang="0">
-                <a:pos x="connsiteX2" y="connsiteY2"/>
-              </a:cxn>
-              <a:cxn ang="0">
-                <a:pos x="connsiteX3" y="connsiteY3"/>
-              </a:cxn>
-            </a:cxnLst>
-            <a:rect l="l" t="t" r="r" b="b"/>
-            <a:pathLst>
-              <a:path w="2835357" h="1480837">
-                <a:moveTo>
-                  <a:pt x="2835357" y="1480837"/>
-                </a:moveTo>
-                <a:lnTo>
-                  <a:pt x="0" y="1480837"/>
-                </a:lnTo>
-                <a:lnTo>
-                  <a:pt x="1552727" y="0"/>
-                </a:lnTo>
-                <a:lnTo>
-                  <a:pt x="2835357" y="1223245"/>
-                </a:lnTo>
-                <a:close/>
-              </a:path>
-            </a:pathLst>
-          </a:custGeom>
-          <a:solidFill>
-            <a:schemeClr val="accent4">
-              <a:alpha val="30000"/>
-            </a:schemeClr>
-          </a:solidFill>
-          <a:ln>
-            <a:noFill/>
-          </a:ln>
-        </p:spPr>
-        <p:style>
-          <a:lnRef idx="2">
-            <a:schemeClr val="accent1">
-              <a:shade val="50000"/>
-            </a:schemeClr>
-          </a:lnRef>
-          <a:fillRef idx="1">
-            <a:schemeClr val="accent1"/>
-          </a:fillRef>
-          <a:effectRef idx="0">
-            <a:schemeClr val="accent1"/>
-          </a:effectRef>
-          <a:fontRef idx="minor">
-            <a:schemeClr val="lt1"/>
-          </a:fontRef>
-        </p:style>
-        <p:txBody>
-          <a:bodyPr wrap="square" rtlCol="0" anchor="ctr">
-            <a:noAutofit/>
-          </a:bodyPr>
-          <a:lstStyle/>
-          <a:p>
-            <a:pPr algn="ctr"/>
-            <a:endParaRPr lang="en-US" dirty="0"/>
-          </a:p>
-        </p:txBody>
-      </p:sp>
-      <p:sp>
-        <p:nvSpPr>
-          <p:cNvPr id="18" name="Isosceles Triangle 17">
-            <a:extLst>
-              <a:ext uri="{FF2B5EF4-FFF2-40B4-BE49-F238E27FC236}">
-                <a16:creationId xmlns:a16="http://schemas.microsoft.com/office/drawing/2014/main" id="{FF9F2414-84E8-453E-B1F3-389FDE8192D9}"/>
-              </a:ext>
-              <a:ext uri="{C183D7F6-B498-43B3-948B-1728B52AA6E4}">
-                <adec:decorative xmlns:adec="http://schemas.microsoft.com/office/drawing/2017/decorative" val="1"/>
-              </a:ext>
-            </a:extLst>
-          </p:cNvPr>
-          <p:cNvSpPr>
-            <a:spLocks noGrp="1" noRot="1" noChangeAspect="1" noMove="1" noResize="1" noEditPoints="1" noAdjustHandles="1" noChangeArrowheads="1" noChangeShapeType="1" noTextEdit="1"/>
-          </p:cNvSpPr>
-          <p:nvPr>
-            <p:extLst>
-              <p:ext uri="{386F3935-93C4-4BCD-93E2-E3B085C9AB24}">
-                <p16:designElem xmlns:p16="http://schemas.microsoft.com/office/powerpoint/2015/main" val="1"/>
-              </p:ext>
-            </p:extLst>
-          </p:nvPr>
-        </p:nvSpPr>
-        <p:spPr>
-          <a:xfrm flipH="1">
-            <a:off x="7976344" y="6115501"/>
-            <a:ext cx="1494513" cy="742499"/>
-          </a:xfrm>
-          <a:prstGeom prst="triangle">
-            <a:avLst/>
-          </a:prstGeom>
-          <a:solidFill>
-            <a:schemeClr val="accent1">
-              <a:alpha val="30000"/>
-            </a:schemeClr>
-          </a:solidFill>
-          <a:ln>
-            <a:noFill/>
-          </a:ln>
-        </p:spPr>
-        <p:style>
-          <a:lnRef idx="2">
-            <a:schemeClr val="accent1">
-              <a:shade val="50000"/>
-            </a:schemeClr>
-          </a:lnRef>
-          <a:fillRef idx="1">
-            <a:schemeClr val="accent1"/>
-          </a:fillRef>
-          <a:effectRef idx="0">
-            <a:schemeClr val="accent1"/>
-          </a:effectRef>
-          <a:fontRef idx="minor">
-            <a:schemeClr val="lt1"/>
-          </a:fontRef>
-        </p:style>
-        <p:txBody>
-          <a:bodyPr rtlCol="0" anchor="ctr"/>
-          <a:lstStyle/>
-          <a:p>
-            <a:pPr algn="ctr"/>
-            <a:endParaRPr lang="en-US"/>
-          </a:p>
-        </p:txBody>
-      </p:sp>
-      <p:pic>
-        <p:nvPicPr>
-          <p:cNvPr id="3" name="Imagen 2">
-            <a:extLst>
-              <a:ext uri="{FF2B5EF4-FFF2-40B4-BE49-F238E27FC236}">
-                <a16:creationId xmlns:a16="http://schemas.microsoft.com/office/drawing/2014/main" id="{10439659-C619-B1BC-7A61-09A890FD605F}"/>
-              </a:ext>
-            </a:extLst>
-          </p:cNvPr>
-          <p:cNvPicPr>
-            <a:picLocks noChangeAspect="1"/>
-          </p:cNvPicPr>
-          <p:nvPr/>
-        </p:nvPicPr>
-        <p:blipFill>
-          <a:blip r:embed="rId2">
-            <a:extLst>
-              <a:ext uri="{28A0092B-C50C-407E-A947-70E740481C1C}">
-                <a14:useLocalDpi xmlns:a14="http://schemas.microsoft.com/office/drawing/2010/main" val="0"/>
-              </a:ext>
-            </a:extLst>
-          </a:blip>
-          <a:stretch>
-            <a:fillRect/>
-          </a:stretch>
-        </p:blipFill>
-        <p:spPr>
-          <a:xfrm>
-            <a:off x="643467" y="1520613"/>
-            <a:ext cx="10905066" cy="3816772"/>
-          </a:xfrm>
-          <a:prstGeom prst="rect">
-            <a:avLst/>
-          </a:prstGeom>
-          <a:ln>
-            <a:noFill/>
-          </a:ln>
-        </p:spPr>
-      </p:pic>
-      <p:sp>
-        <p:nvSpPr>
-          <p:cNvPr id="20" name="Isosceles Triangle 19">
-            <a:extLst>
-              <a:ext uri="{FF2B5EF4-FFF2-40B4-BE49-F238E27FC236}">
-                <a16:creationId xmlns:a16="http://schemas.microsoft.com/office/drawing/2014/main" id="{3ECA69A1-7536-43AC-85EF-C7106179F5ED}"/>
-              </a:ext>
-              <a:ext uri="{C183D7F6-B498-43B3-948B-1728B52AA6E4}">
-                <adec:decorative xmlns:adec="http://schemas.microsoft.com/office/drawing/2017/decorative" val="1"/>
-              </a:ext>
-            </a:extLst>
-          </p:cNvPr>
-          <p:cNvSpPr>
-            <a:spLocks noGrp="1" noRot="1" noChangeAspect="1" noMove="1" noResize="1" noEditPoints="1" noAdjustHandles="1" noChangeArrowheads="1" noChangeShapeType="1" noTextEdit="1"/>
-          </p:cNvSpPr>
-          <p:nvPr>
-            <p:extLst>
-              <p:ext uri="{386F3935-93C4-4BCD-93E2-E3B085C9AB24}">
-                <p16:designElem xmlns:p16="http://schemas.microsoft.com/office/powerpoint/2015/main" val="1"/>
-              </p:ext>
-            </p:extLst>
-          </p:nvPr>
-        </p:nvSpPr>
-        <p:spPr>
-          <a:xfrm flipH="1">
-            <a:off x="7604080" y="6453143"/>
-            <a:ext cx="814903" cy="404857"/>
-          </a:xfrm>
-          <a:prstGeom prst="triangle">
-            <a:avLst/>
-          </a:prstGeom>
-          <a:solidFill>
-            <a:schemeClr val="accent1">
-              <a:alpha val="30000"/>
-            </a:schemeClr>
-          </a:solidFill>
-          <a:ln>
-            <a:noFill/>
-          </a:ln>
-        </p:spPr>
-        <p:style>
-          <a:lnRef idx="2">
-            <a:schemeClr val="accent1">
-              <a:shade val="50000"/>
-            </a:schemeClr>
-          </a:lnRef>
-          <a:fillRef idx="1">
-            <a:schemeClr val="accent1"/>
-          </a:fillRef>
-          <a:effectRef idx="0">
-            <a:schemeClr val="accent1"/>
-          </a:effectRef>
-          <a:fontRef idx="minor">
-            <a:schemeClr val="lt1"/>
-          </a:fontRef>
-        </p:style>
-        <p:txBody>
-          <a:bodyPr rtlCol="0" anchor="ctr"/>
-          <a:lstStyle/>
-          <a:p>
-            <a:pPr algn="ctr"/>
-            <a:endParaRPr lang="en-US"/>
-          </a:p>
-        </p:txBody>
-      </p:sp>
-      <p:sp>
-        <p:nvSpPr>
-          <p:cNvPr id="5" name="CuadroTexto 4">
-            <a:extLst>
-              <a:ext uri="{FF2B5EF4-FFF2-40B4-BE49-F238E27FC236}">
-                <a16:creationId xmlns:a16="http://schemas.microsoft.com/office/drawing/2014/main" id="{A2619C58-CA1A-0779-DCDF-63269017A7D0}"/>
-              </a:ext>
-            </a:extLst>
-          </p:cNvPr>
-          <p:cNvSpPr txBox="1"/>
-          <p:nvPr/>
-        </p:nvSpPr>
-        <p:spPr>
-          <a:xfrm>
-            <a:off x="4468218" y="250158"/>
-            <a:ext cx="3255564" cy="369332"/>
-          </a:xfrm>
-          <a:prstGeom prst="rect">
-            <a:avLst/>
-          </a:prstGeom>
-          <a:noFill/>
-          <a:ln w="38100" cap="flat" cmpd="sng" algn="ctr">
-            <a:solidFill>
-              <a:schemeClr val="accent2"/>
-            </a:solidFill>
-            <a:prstDash val="solid"/>
-            <a:round/>
-            <a:headEnd type="none" w="med" len="med"/>
-            <a:tailEnd type="none" w="med" len="med"/>
-          </a:ln>
-        </p:spPr>
-        <p:style>
-          <a:lnRef idx="0">
-            <a:scrgbClr r="0" g="0" b="0"/>
-          </a:lnRef>
-          <a:fillRef idx="0">
-            <a:scrgbClr r="0" g="0" b="0"/>
-          </a:fillRef>
-          <a:effectRef idx="0">
-            <a:scrgbClr r="0" g="0" b="0"/>
-          </a:effectRef>
-          <a:fontRef idx="minor">
-            <a:schemeClr val="accent2"/>
-          </a:fontRef>
-        </p:style>
-        <p:txBody>
-          <a:bodyPr wrap="square" rtlCol="0">
-            <a:spAutoFit/>
-          </a:bodyPr>
-          <a:lstStyle/>
-          <a:p>
-            <a:pPr algn="ctr"/>
-            <a:r>
-              <a:rPr lang="es-CO" b="1" dirty="0"/>
-              <a:t>Gestión de </a:t>
-            </a:r>
-            <a:r>
-              <a:rPr lang="es-CO" b="1" dirty="0" err="1"/>
-              <a:t>Vecimientos</a:t>
-            </a:r>
-            <a:endParaRPr lang="es-CO" b="1" dirty="0"/>
-          </a:p>
-        </p:txBody>
-      </p:sp>
-    </p:spTree>
-    <p:extLst>
-      <p:ext uri="{BB962C8B-B14F-4D97-AF65-F5344CB8AC3E}">
-        <p14:creationId xmlns:p14="http://schemas.microsoft.com/office/powerpoint/2010/main" val="843671556"/>
+        <p14:creationId xmlns:p14="http://schemas.microsoft.com/office/powerpoint/2010/main" val="4068809485"/>
       </p:ext>
     </p:extLst>
   </p:cSld>

</xml_diff>

<commit_message>
refactor: simplify PWA configuration and service worker
</commit_message>
<xml_diff>
--- a/PAIC Redes.pptx
+++ b/PAIC Redes.pptx
@@ -5,18 +5,19 @@
     <p:sldMasterId id="2147483648" r:id="rId1"/>
   </p:sldMasterIdLst>
   <p:sldIdLst>
-    <p:sldId id="257" r:id="rId2"/>
-    <p:sldId id="258" r:id="rId3"/>
-    <p:sldId id="259" r:id="rId4"/>
-    <p:sldId id="260" r:id="rId5"/>
-    <p:sldId id="261" r:id="rId6"/>
-    <p:sldId id="262" r:id="rId7"/>
-    <p:sldId id="263" r:id="rId8"/>
-    <p:sldId id="264" r:id="rId9"/>
-    <p:sldId id="265" r:id="rId10"/>
-    <p:sldId id="266" r:id="rId11"/>
-    <p:sldId id="267" r:id="rId12"/>
-    <p:sldId id="268" r:id="rId13"/>
+    <p:sldId id="256" r:id="rId2"/>
+    <p:sldId id="257" r:id="rId3"/>
+    <p:sldId id="258" r:id="rId4"/>
+    <p:sldId id="259" r:id="rId5"/>
+    <p:sldId id="260" r:id="rId6"/>
+    <p:sldId id="261" r:id="rId7"/>
+    <p:sldId id="262" r:id="rId8"/>
+    <p:sldId id="263" r:id="rId9"/>
+    <p:sldId id="264" r:id="rId10"/>
+    <p:sldId id="265" r:id="rId11"/>
+    <p:sldId id="266" r:id="rId12"/>
+    <p:sldId id="267" r:id="rId13"/>
+    <p:sldId id="268" r:id="rId14"/>
   </p:sldIdLst>
   <p:sldSz cx="12192000" cy="6858000"/>
   <p:notesSz cx="6858000" cy="9144000"/>
@@ -123,27 +124,6 @@
 </p:presentation>
 </file>
 
-<file path=ppt/changesInfos/changesInfo1.xml><?xml version="1.0" encoding="utf-8"?>
-<pc:chgInfo xmlns:a="http://schemas.openxmlformats.org/drawingml/2006/main" xmlns:r="http://schemas.openxmlformats.org/officeDocument/2006/relationships" xmlns:ac="http://schemas.microsoft.com/office/drawing/2013/main/command" xmlns:pc="http://schemas.microsoft.com/office/powerpoint/2013/main/command">
-  <pc:docChgLst>
-    <pc:chgData name="Héctor Mauricio Pineda" userId="c7e756c87e1902e4" providerId="LiveId" clId="{BC815025-23A5-4E5B-B84B-7A9DC51BF681}"/>
-    <pc:docChg chg="delSld">
-      <pc:chgData name="Héctor Mauricio Pineda" userId="c7e756c87e1902e4" providerId="LiveId" clId="{BC815025-23A5-4E5B-B84B-7A9DC51BF681}" dt="2026-09-28T16:04:30.913" v="0" actId="2696"/>
-      <pc:docMkLst>
-        <pc:docMk/>
-      </pc:docMkLst>
-      <pc:sldChg chg="del">
-        <pc:chgData name="Héctor Mauricio Pineda" userId="c7e756c87e1902e4" providerId="LiveId" clId="{BC815025-23A5-4E5B-B84B-7A9DC51BF681}" dt="2026-09-28T16:04:30.913" v="0" actId="2696"/>
-        <pc:sldMkLst>
-          <pc:docMk/>
-          <pc:sldMk cId="2791466258" sldId="256"/>
-        </pc:sldMkLst>
-      </pc:sldChg>
-    </pc:docChg>
-  </pc:docChgLst>
-</pc:chgInfo>
-</file>
-
 <file path=ppt/slideLayouts/slideLayout1.xml><?xml version="1.0" encoding="utf-8"?>
 <p:sldLayout xmlns:a="http://schemas.openxmlformats.org/drawingml/2006/main" xmlns:r="http://schemas.openxmlformats.org/officeDocument/2006/relationships" xmlns:p="http://schemas.openxmlformats.org/presentationml/2006/main" type="title" preserve="1">
   <p:cSld name="Diapositiva de título">
@@ -293,7 +273,7 @@
           <a:p>
             <a:fld id="{BA8FD21E-C980-46DC-9E43-6C64DF0F21CF}" type="datetimeFigureOut">
               <a:rPr lang="es-CO" smtClean="0"/>
-              <a:t>28/09/2026</a:t>
+              <a:t>18/07/2026</a:t>
             </a:fld>
             <a:endParaRPr lang="es-CO"/>
           </a:p>
@@ -493,7 +473,7 @@
           <a:p>
             <a:fld id="{BA8FD21E-C980-46DC-9E43-6C64DF0F21CF}" type="datetimeFigureOut">
               <a:rPr lang="es-CO" smtClean="0"/>
-              <a:t>28/09/2026</a:t>
+              <a:t>18/07/2026</a:t>
             </a:fld>
             <a:endParaRPr lang="es-CO"/>
           </a:p>
@@ -703,7 +683,7 @@
           <a:p>
             <a:fld id="{BA8FD21E-C980-46DC-9E43-6C64DF0F21CF}" type="datetimeFigureOut">
               <a:rPr lang="es-CO" smtClean="0"/>
-              <a:t>28/09/2026</a:t>
+              <a:t>18/07/2026</a:t>
             </a:fld>
             <a:endParaRPr lang="es-CO"/>
           </a:p>
@@ -903,7 +883,7 @@
           <a:p>
             <a:fld id="{BA8FD21E-C980-46DC-9E43-6C64DF0F21CF}" type="datetimeFigureOut">
               <a:rPr lang="es-CO" smtClean="0"/>
-              <a:t>28/09/2026</a:t>
+              <a:t>18/07/2026</a:t>
             </a:fld>
             <a:endParaRPr lang="es-CO"/>
           </a:p>
@@ -1179,7 +1159,7 @@
           <a:p>
             <a:fld id="{BA8FD21E-C980-46DC-9E43-6C64DF0F21CF}" type="datetimeFigureOut">
               <a:rPr lang="es-CO" smtClean="0"/>
-              <a:t>28/09/2026</a:t>
+              <a:t>18/07/2026</a:t>
             </a:fld>
             <a:endParaRPr lang="es-CO"/>
           </a:p>
@@ -1447,7 +1427,7 @@
           <a:p>
             <a:fld id="{BA8FD21E-C980-46DC-9E43-6C64DF0F21CF}" type="datetimeFigureOut">
               <a:rPr lang="es-CO" smtClean="0"/>
-              <a:t>28/09/2026</a:t>
+              <a:t>18/07/2026</a:t>
             </a:fld>
             <a:endParaRPr lang="es-CO"/>
           </a:p>
@@ -1862,7 +1842,7 @@
           <a:p>
             <a:fld id="{BA8FD21E-C980-46DC-9E43-6C64DF0F21CF}" type="datetimeFigureOut">
               <a:rPr lang="es-CO" smtClean="0"/>
-              <a:t>28/09/2026</a:t>
+              <a:t>18/07/2026</a:t>
             </a:fld>
             <a:endParaRPr lang="es-CO"/>
           </a:p>
@@ -2004,7 +1984,7 @@
           <a:p>
             <a:fld id="{BA8FD21E-C980-46DC-9E43-6C64DF0F21CF}" type="datetimeFigureOut">
               <a:rPr lang="es-CO" smtClean="0"/>
-              <a:t>28/09/2026</a:t>
+              <a:t>18/07/2026</a:t>
             </a:fld>
             <a:endParaRPr lang="es-CO"/>
           </a:p>
@@ -2117,7 +2097,7 @@
           <a:p>
             <a:fld id="{BA8FD21E-C980-46DC-9E43-6C64DF0F21CF}" type="datetimeFigureOut">
               <a:rPr lang="es-CO" smtClean="0"/>
-              <a:t>28/09/2026</a:t>
+              <a:t>18/07/2026</a:t>
             </a:fld>
             <a:endParaRPr lang="es-CO"/>
           </a:p>
@@ -2430,7 +2410,7 @@
           <a:p>
             <a:fld id="{BA8FD21E-C980-46DC-9E43-6C64DF0F21CF}" type="datetimeFigureOut">
               <a:rPr lang="es-CO" smtClean="0"/>
-              <a:t>28/09/2026</a:t>
+              <a:t>18/07/2026</a:t>
             </a:fld>
             <a:endParaRPr lang="es-CO"/>
           </a:p>
@@ -2719,7 +2699,7 @@
           <a:p>
             <a:fld id="{BA8FD21E-C980-46DC-9E43-6C64DF0F21CF}" type="datetimeFigureOut">
               <a:rPr lang="es-CO" smtClean="0"/>
-              <a:t>28/09/2026</a:t>
+              <a:t>18/07/2026</a:t>
             </a:fld>
             <a:endParaRPr lang="es-CO"/>
           </a:p>
@@ -2962,7 +2942,7 @@
           <a:p>
             <a:fld id="{BA8FD21E-C980-46DC-9E43-6C64DF0F21CF}" type="datetimeFigureOut">
               <a:rPr lang="es-CO" smtClean="0"/>
-              <a:t>28/09/2026</a:t>
+              <a:t>18/07/2026</a:t>
             </a:fld>
             <a:endParaRPr lang="es-CO"/>
           </a:p>
@@ -3568,7 +3548,7 @@
       </p:sp>
       <p:sp>
         <p:nvSpPr>
-          <p:cNvPr id="12" name="Rectangle 11">
+          <p:cNvPr id="5" name="Rectangle 11">
             <a:extLst>
               <a:ext uri="{FF2B5EF4-FFF2-40B4-BE49-F238E27FC236}">
                 <a16:creationId xmlns:a16="http://schemas.microsoft.com/office/drawing/2014/main" id="{29FDB030-9B49-4CED-8CCD-4D99382388AC}"/>
@@ -3876,7 +3856,7 @@
           <p:cNvPr id="3" name="Imagen 2">
             <a:extLst>
               <a:ext uri="{FF2B5EF4-FFF2-40B4-BE49-F238E27FC236}">
-                <a16:creationId xmlns:a16="http://schemas.microsoft.com/office/drawing/2014/main" id="{BDE039E2-8D9A-A968-78B0-40BC90031E73}"/>
+                <a16:creationId xmlns:a16="http://schemas.microsoft.com/office/drawing/2014/main" id="{41F08D15-8F0D-71BF-A5DA-D67E251FFD13}"/>
               </a:ext>
             </a:extLst>
           </p:cNvPr>
@@ -3899,8 +3879,8 @@
         </p:blipFill>
         <p:spPr>
           <a:xfrm>
-            <a:off x="1187573" y="643467"/>
-            <a:ext cx="9816854" cy="5571065"/>
+            <a:off x="3144358" y="643467"/>
+            <a:ext cx="5903283" cy="5571065"/>
           </a:xfrm>
           <a:prstGeom prst="rect">
             <a:avLst/>
@@ -3975,69 +3955,10 @@
           </a:p>
         </p:txBody>
       </p:sp>
-      <p:sp>
-        <p:nvSpPr>
-          <p:cNvPr id="4" name="CuadroTexto 3">
-            <a:extLst>
-              <a:ext uri="{FF2B5EF4-FFF2-40B4-BE49-F238E27FC236}">
-                <a16:creationId xmlns:a16="http://schemas.microsoft.com/office/drawing/2014/main" id="{CF798E75-5B85-AFF9-5448-E23C8AD18F35}"/>
-              </a:ext>
-            </a:extLst>
-          </p:cNvPr>
-          <p:cNvSpPr txBox="1"/>
-          <p:nvPr/>
-        </p:nvSpPr>
-        <p:spPr>
-          <a:xfrm>
-            <a:off x="4678321" y="133350"/>
-            <a:ext cx="2835357" cy="379409"/>
-          </a:xfrm>
-          <a:prstGeom prst="rect">
-            <a:avLst/>
-          </a:prstGeom>
-          <a:noFill/>
-          <a:ln w="38100" cap="flat" cmpd="sng" algn="ctr">
-            <a:solidFill>
-              <a:schemeClr val="accent2"/>
-            </a:solidFill>
-            <a:prstDash val="solid"/>
-            <a:round/>
-            <a:headEnd type="none" w="med" len="med"/>
-            <a:tailEnd type="none" w="med" len="med"/>
-          </a:ln>
-        </p:spPr>
-        <p:style>
-          <a:lnRef idx="0">
-            <a:scrgbClr r="0" g="0" b="0"/>
-          </a:lnRef>
-          <a:fillRef idx="0">
-            <a:scrgbClr r="0" g="0" b="0"/>
-          </a:fillRef>
-          <a:effectRef idx="0">
-            <a:scrgbClr r="0" g="0" b="0"/>
-          </a:effectRef>
-          <a:fontRef idx="minor">
-            <a:schemeClr val="accent2"/>
-          </a:fontRef>
-        </p:style>
-        <p:txBody>
-          <a:bodyPr wrap="square" rtlCol="0">
-            <a:spAutoFit/>
-          </a:bodyPr>
-          <a:lstStyle/>
-          <a:p>
-            <a:pPr algn="ctr"/>
-            <a:r>
-              <a:rPr lang="es-CO" b="1" dirty="0"/>
-              <a:t>Panel de control</a:t>
-            </a:r>
-          </a:p>
-        </p:txBody>
-      </p:sp>
     </p:spTree>
     <p:extLst>
       <p:ext uri="{BB962C8B-B14F-4D97-AF65-F5344CB8AC3E}">
-        <p14:creationId xmlns:p14="http://schemas.microsoft.com/office/powerpoint/2010/main" val="3376057791"/>
+        <p14:creationId xmlns:p14="http://schemas.microsoft.com/office/powerpoint/2010/main" val="2791466258"/>
       </p:ext>
     </p:extLst>
   </p:cSld>
@@ -4561,7 +4482,7 @@
           <p:cNvPr id="3" name="Imagen 2">
             <a:extLst>
               <a:ext uri="{FF2B5EF4-FFF2-40B4-BE49-F238E27FC236}">
-                <a16:creationId xmlns:a16="http://schemas.microsoft.com/office/drawing/2014/main" id="{D2597954-0A94-78B9-0F16-BE040D931F4D}"/>
+                <a16:creationId xmlns:a16="http://schemas.microsoft.com/office/drawing/2014/main" id="{4E0CFFBE-8F93-5A2A-3593-8B1C2315A87F}"/>
               </a:ext>
             </a:extLst>
           </p:cNvPr>
@@ -4584,8 +4505,8 @@
         </p:blipFill>
         <p:spPr>
           <a:xfrm>
-            <a:off x="864952" y="643467"/>
-            <a:ext cx="10462095" cy="5571065"/>
+            <a:off x="643467" y="1861396"/>
+            <a:ext cx="10905066" cy="3135206"/>
           </a:xfrm>
           <a:prstGeom prst="rect">
             <a:avLst/>
@@ -4665,7 +4586,7 @@
           <p:cNvPr id="5" name="CuadroTexto 4">
             <a:extLst>
               <a:ext uri="{FF2B5EF4-FFF2-40B4-BE49-F238E27FC236}">
-                <a16:creationId xmlns:a16="http://schemas.microsoft.com/office/drawing/2014/main" id="{4BC7D0A7-59EC-B498-288B-93FDF9D47C45}"/>
+                <a16:creationId xmlns:a16="http://schemas.microsoft.com/office/drawing/2014/main" id="{1AA30F0F-F6BA-0152-7664-46AB10BB2E08}"/>
               </a:ext>
             </a:extLst>
           </p:cNvPr>
@@ -4714,7 +4635,7 @@
             <a:pPr algn="ctr"/>
             <a:r>
               <a:rPr lang="es-CO" b="1" dirty="0"/>
-              <a:t>Configuración de PAIC</a:t>
+              <a:t>Gestión de tareas</a:t>
             </a:r>
           </a:p>
         </p:txBody>
@@ -4722,7 +4643,7 @@
     </p:spTree>
     <p:extLst>
       <p:ext uri="{BB962C8B-B14F-4D97-AF65-F5344CB8AC3E}">
-        <p14:creationId xmlns:p14="http://schemas.microsoft.com/office/powerpoint/2010/main" val="295797952"/>
+        <p14:creationId xmlns:p14="http://schemas.microsoft.com/office/powerpoint/2010/main" val="4068809485"/>
       </p:ext>
     </p:extLst>
   </p:cSld>
@@ -5246,7 +5167,7 @@
           <p:cNvPr id="3" name="Imagen 2">
             <a:extLst>
               <a:ext uri="{FF2B5EF4-FFF2-40B4-BE49-F238E27FC236}">
-                <a16:creationId xmlns:a16="http://schemas.microsoft.com/office/drawing/2014/main" id="{72D077F4-8A7E-5E69-C37C-3787184E875F}"/>
+                <a16:creationId xmlns:a16="http://schemas.microsoft.com/office/drawing/2014/main" id="{D2597954-0A94-78B9-0F16-BE040D931F4D}"/>
               </a:ext>
             </a:extLst>
           </p:cNvPr>
@@ -5269,8 +5190,8 @@
         </p:blipFill>
         <p:spPr>
           <a:xfrm>
-            <a:off x="3777044" y="643467"/>
-            <a:ext cx="4637911" cy="5571065"/>
+            <a:off x="864952" y="643467"/>
+            <a:ext cx="10462095" cy="5571065"/>
           </a:xfrm>
           <a:prstGeom prst="rect">
             <a:avLst/>
@@ -5350,7 +5271,7 @@
           <p:cNvPr id="5" name="CuadroTexto 4">
             <a:extLst>
               <a:ext uri="{FF2B5EF4-FFF2-40B4-BE49-F238E27FC236}">
-                <a16:creationId xmlns:a16="http://schemas.microsoft.com/office/drawing/2014/main" id="{6210E176-D124-6EFB-528C-295E72F6762A}"/>
+                <a16:creationId xmlns:a16="http://schemas.microsoft.com/office/drawing/2014/main" id="{4BC7D0A7-59EC-B498-288B-93FDF9D47C45}"/>
               </a:ext>
             </a:extLst>
           </p:cNvPr>
@@ -5399,7 +5320,7 @@
             <a:pPr algn="ctr"/>
             <a:r>
               <a:rPr lang="es-CO" b="1" dirty="0"/>
-              <a:t>Soporte PAIC</a:t>
+              <a:t>Configuración de PAIC</a:t>
             </a:r>
           </a:p>
         </p:txBody>
@@ -5407,7 +5328,7 @@
     </p:spTree>
     <p:extLst>
       <p:ext uri="{BB962C8B-B14F-4D97-AF65-F5344CB8AC3E}">
-        <p14:creationId xmlns:p14="http://schemas.microsoft.com/office/powerpoint/2010/main" val="2533460273"/>
+        <p14:creationId xmlns:p14="http://schemas.microsoft.com/office/powerpoint/2010/main" val="295797952"/>
       </p:ext>
     </p:extLst>
   </p:cSld>
@@ -5444,7 +5365,7 @@
       </p:grpSpPr>
       <p:sp>
         <p:nvSpPr>
-          <p:cNvPr id="10" name="Rectangle 9">
+          <p:cNvPr id="8" name="Rectangle 7">
             <a:extLst>
               <a:ext uri="{FF2B5EF4-FFF2-40B4-BE49-F238E27FC236}">
                 <a16:creationId xmlns:a16="http://schemas.microsoft.com/office/drawing/2014/main" id="{F3060C83-F051-4F0E-ABAD-AA0DFC48B218}"/>
@@ -5507,7 +5428,7 @@
       </p:sp>
       <p:sp>
         <p:nvSpPr>
-          <p:cNvPr id="12" name="Freeform: Shape 11">
+          <p:cNvPr id="10" name="Freeform: Shape 9">
             <a:extLst>
               <a:ext uri="{FF2B5EF4-FFF2-40B4-BE49-F238E27FC236}">
                 <a16:creationId xmlns:a16="http://schemas.microsoft.com/office/drawing/2014/main" id="{83C98ABE-055B-441F-B07E-44F97F083C39}"/>
@@ -5623,7 +5544,7 @@
       </p:sp>
       <p:sp>
         <p:nvSpPr>
-          <p:cNvPr id="14" name="Rectangle 13">
+          <p:cNvPr id="12" name="Rectangle 11">
             <a:extLst>
               <a:ext uri="{FF2B5EF4-FFF2-40B4-BE49-F238E27FC236}">
                 <a16:creationId xmlns:a16="http://schemas.microsoft.com/office/drawing/2014/main" id="{29FDB030-9B49-4CED-8CCD-4D99382388AC}"/>
@@ -5688,7 +5609,7 @@
       </p:sp>
       <p:sp>
         <p:nvSpPr>
-          <p:cNvPr id="16" name="Rectangle 15">
+          <p:cNvPr id="14" name="Rectangle 13">
             <a:extLst>
               <a:ext uri="{FF2B5EF4-FFF2-40B4-BE49-F238E27FC236}">
                 <a16:creationId xmlns:a16="http://schemas.microsoft.com/office/drawing/2014/main" id="{3783CA14-24A1-485C-8B30-D6A5D87987AD}"/>
@@ -5753,7 +5674,7 @@
       </p:sp>
       <p:sp>
         <p:nvSpPr>
-          <p:cNvPr id="18" name="Freeform: Shape 17">
+          <p:cNvPr id="16" name="Freeform: Shape 15">
             <a:extLst>
               <a:ext uri="{FF2B5EF4-FFF2-40B4-BE49-F238E27FC236}">
                 <a16:creationId xmlns:a16="http://schemas.microsoft.com/office/drawing/2014/main" id="{9A97C86A-04D6-40F7-AE84-31AB43E6A846}"/>
@@ -5863,7 +5784,7 @@
       </p:sp>
       <p:sp>
         <p:nvSpPr>
-          <p:cNvPr id="20" name="Isosceles Triangle 19">
+          <p:cNvPr id="18" name="Isosceles Triangle 17">
             <a:extLst>
               <a:ext uri="{FF2B5EF4-FFF2-40B4-BE49-F238E27FC236}">
                 <a16:creationId xmlns:a16="http://schemas.microsoft.com/office/drawing/2014/main" id="{FF9F2414-84E8-453E-B1F3-389FDE8192D9}"/>
@@ -5928,10 +5849,10 @@
       </p:sp>
       <p:pic>
         <p:nvPicPr>
-          <p:cNvPr id="5" name="Imagen 4">
-            <a:extLst>
-              <a:ext uri="{FF2B5EF4-FFF2-40B4-BE49-F238E27FC236}">
-                <a16:creationId xmlns:a16="http://schemas.microsoft.com/office/drawing/2014/main" id="{A8517BAD-3EC3-B1FB-9E67-BB587731E724}"/>
+          <p:cNvPr id="3" name="Imagen 2">
+            <a:extLst>
+              <a:ext uri="{FF2B5EF4-FFF2-40B4-BE49-F238E27FC236}">
+                <a16:creationId xmlns:a16="http://schemas.microsoft.com/office/drawing/2014/main" id="{72D077F4-8A7E-5E69-C37C-3787184E875F}"/>
               </a:ext>
             </a:extLst>
           </p:cNvPr>
@@ -5954,8 +5875,8 @@
         </p:blipFill>
         <p:spPr>
           <a:xfrm>
-            <a:off x="643467" y="907203"/>
-            <a:ext cx="10905066" cy="5043592"/>
+            <a:off x="3777044" y="643467"/>
+            <a:ext cx="4637911" cy="5571065"/>
           </a:xfrm>
           <a:prstGeom prst="rect">
             <a:avLst/>
@@ -5967,7 +5888,7 @@
       </p:pic>
       <p:sp>
         <p:nvSpPr>
-          <p:cNvPr id="22" name="Isosceles Triangle 21">
+          <p:cNvPr id="20" name="Isosceles Triangle 19">
             <a:extLst>
               <a:ext uri="{FF2B5EF4-FFF2-40B4-BE49-F238E27FC236}">
                 <a16:creationId xmlns:a16="http://schemas.microsoft.com/office/drawing/2014/main" id="{3ECA69A1-7536-43AC-85EF-C7106179F5ED}"/>
@@ -6032,10 +5953,10 @@
       </p:sp>
       <p:sp>
         <p:nvSpPr>
-          <p:cNvPr id="13" name="CuadroTexto 12">
-            <a:extLst>
-              <a:ext uri="{FF2B5EF4-FFF2-40B4-BE49-F238E27FC236}">
-                <a16:creationId xmlns:a16="http://schemas.microsoft.com/office/drawing/2014/main" id="{A4D04D02-52A3-897F-783B-700822F77E93}"/>
+          <p:cNvPr id="5" name="CuadroTexto 4">
+            <a:extLst>
+              <a:ext uri="{FF2B5EF4-FFF2-40B4-BE49-F238E27FC236}">
+                <a16:creationId xmlns:a16="http://schemas.microsoft.com/office/drawing/2014/main" id="{6210E176-D124-6EFB-528C-295E72F6762A}"/>
               </a:ext>
             </a:extLst>
           </p:cNvPr>
@@ -6084,111 +6005,15 @@
             <a:pPr algn="ctr"/>
             <a:r>
               <a:rPr lang="es-CO" b="1" dirty="0"/>
-              <a:t>Aprende PAIC</a:t>
+              <a:t>Soporte PAIC</a:t>
             </a:r>
           </a:p>
         </p:txBody>
       </p:sp>
-      <p:sp>
-        <p:nvSpPr>
-          <p:cNvPr id="6" name="CuadroTexto 5">
-            <a:extLst>
-              <a:ext uri="{FF2B5EF4-FFF2-40B4-BE49-F238E27FC236}">
-                <a16:creationId xmlns:a16="http://schemas.microsoft.com/office/drawing/2014/main" id="{6D4076C0-25EF-7C0A-D718-48B2EC777116}"/>
-              </a:ext>
-            </a:extLst>
-          </p:cNvPr>
-          <p:cNvSpPr txBox="1"/>
-          <p:nvPr/>
-        </p:nvSpPr>
-        <p:spPr>
-          <a:xfrm>
-            <a:off x="6915150" y="148117"/>
-            <a:ext cx="4267200" cy="646331"/>
-          </a:xfrm>
-          <a:prstGeom prst="rect">
-            <a:avLst/>
-          </a:prstGeom>
-          <a:solidFill>
-            <a:schemeClr val="accent2"/>
-          </a:solidFill>
-          <a:ln>
-            <a:noFill/>
-          </a:ln>
-        </p:spPr>
-        <p:style>
-          <a:lnRef idx="0">
-            <a:scrgbClr r="0" g="0" b="0"/>
-          </a:lnRef>
-          <a:fillRef idx="0">
-            <a:scrgbClr r="0" g="0" b="0"/>
-          </a:fillRef>
-          <a:effectRef idx="0">
-            <a:scrgbClr r="0" g="0" b="0"/>
-          </a:effectRef>
-          <a:fontRef idx="minor">
-            <a:schemeClr val="lt1"/>
-          </a:fontRef>
-        </p:style>
-        <p:txBody>
-          <a:bodyPr wrap="square" rtlCol="0">
-            <a:spAutoFit/>
-          </a:bodyPr>
-          <a:lstStyle/>
-          <a:p>
-            <a:pPr algn="ctr"/>
-            <a:r>
-              <a:rPr lang="es-CO" b="1" dirty="0"/>
-              <a:t>Ponte los audífonos y toma el tour guiado, te sorprenderá!</a:t>
-            </a:r>
-          </a:p>
-        </p:txBody>
-      </p:sp>
-      <p:cxnSp>
-        <p:nvCxnSpPr>
-          <p:cNvPr id="8" name="Conector recto de flecha 7">
-            <a:extLst>
-              <a:ext uri="{FF2B5EF4-FFF2-40B4-BE49-F238E27FC236}">
-                <a16:creationId xmlns:a16="http://schemas.microsoft.com/office/drawing/2014/main" id="{E9E99C5F-2D7A-075A-FC52-81DAC6527946}"/>
-              </a:ext>
-            </a:extLst>
-          </p:cNvPr>
-          <p:cNvCxnSpPr>
-            <a:cxnSpLocks/>
-          </p:cNvCxnSpPr>
-          <p:nvPr/>
-        </p:nvCxnSpPr>
-        <p:spPr>
-          <a:xfrm>
-            <a:off x="9161294" y="761796"/>
-            <a:ext cx="563731" cy="237080"/>
-          </a:xfrm>
-          <a:prstGeom prst="straightConnector1">
-            <a:avLst/>
-          </a:prstGeom>
-          <a:ln w="38100">
-            <a:tailEnd type="triangle"/>
-          </a:ln>
-        </p:spPr>
-        <p:style>
-          <a:lnRef idx="2">
-            <a:schemeClr val="accent2"/>
-          </a:lnRef>
-          <a:fillRef idx="0">
-            <a:schemeClr val="accent2"/>
-          </a:fillRef>
-          <a:effectRef idx="1">
-            <a:schemeClr val="accent2"/>
-          </a:effectRef>
-          <a:fontRef idx="minor">
-            <a:schemeClr val="tx1"/>
-          </a:fontRef>
-        </p:style>
-      </p:cxnSp>
     </p:spTree>
     <p:extLst>
       <p:ext uri="{BB962C8B-B14F-4D97-AF65-F5344CB8AC3E}">
-        <p14:creationId xmlns:p14="http://schemas.microsoft.com/office/powerpoint/2010/main" val="4032973602"/>
+        <p14:creationId xmlns:p14="http://schemas.microsoft.com/office/powerpoint/2010/main" val="2533460273"/>
       </p:ext>
     </p:extLst>
   </p:cSld>
@@ -6198,7 +6023,7 @@
 </p:sld>
 </file>
 
-<file path=ppt/slides/slide2.xml><?xml version="1.0" encoding="utf-8"?>
+<file path=ppt/slides/slide13.xml><?xml version="1.0" encoding="utf-8"?>
 <p:sld xmlns:a="http://schemas.openxmlformats.org/drawingml/2006/main" xmlns:r="http://schemas.openxmlformats.org/officeDocument/2006/relationships" xmlns:p="http://schemas.openxmlformats.org/presentationml/2006/main">
   <p:cSld>
     <p:bg>
@@ -6225,7 +6050,7 @@
       </p:grpSpPr>
       <p:sp>
         <p:nvSpPr>
-          <p:cNvPr id="8" name="Rectangle 7">
+          <p:cNvPr id="10" name="Rectangle 9">
             <a:extLst>
               <a:ext uri="{FF2B5EF4-FFF2-40B4-BE49-F238E27FC236}">
                 <a16:creationId xmlns:a16="http://schemas.microsoft.com/office/drawing/2014/main" id="{F3060C83-F051-4F0E-ABAD-AA0DFC48B218}"/>
@@ -6288,7 +6113,7 @@
       </p:sp>
       <p:sp>
         <p:nvSpPr>
-          <p:cNvPr id="10" name="Freeform: Shape 9">
+          <p:cNvPr id="12" name="Freeform: Shape 11">
             <a:extLst>
               <a:ext uri="{FF2B5EF4-FFF2-40B4-BE49-F238E27FC236}">
                 <a16:creationId xmlns:a16="http://schemas.microsoft.com/office/drawing/2014/main" id="{83C98ABE-055B-441F-B07E-44F97F083C39}"/>
@@ -6404,7 +6229,7 @@
       </p:sp>
       <p:sp>
         <p:nvSpPr>
-          <p:cNvPr id="12" name="Rectangle 11">
+          <p:cNvPr id="14" name="Rectangle 13">
             <a:extLst>
               <a:ext uri="{FF2B5EF4-FFF2-40B4-BE49-F238E27FC236}">
                 <a16:creationId xmlns:a16="http://schemas.microsoft.com/office/drawing/2014/main" id="{29FDB030-9B49-4CED-8CCD-4D99382388AC}"/>
@@ -6469,7 +6294,7 @@
       </p:sp>
       <p:sp>
         <p:nvSpPr>
-          <p:cNvPr id="14" name="Rectangle 13">
+          <p:cNvPr id="16" name="Rectangle 15">
             <a:extLst>
               <a:ext uri="{FF2B5EF4-FFF2-40B4-BE49-F238E27FC236}">
                 <a16:creationId xmlns:a16="http://schemas.microsoft.com/office/drawing/2014/main" id="{3783CA14-24A1-485C-8B30-D6A5D87987AD}"/>
@@ -6534,7 +6359,7 @@
       </p:sp>
       <p:sp>
         <p:nvSpPr>
-          <p:cNvPr id="16" name="Freeform: Shape 15">
+          <p:cNvPr id="18" name="Freeform: Shape 17">
             <a:extLst>
               <a:ext uri="{FF2B5EF4-FFF2-40B4-BE49-F238E27FC236}">
                 <a16:creationId xmlns:a16="http://schemas.microsoft.com/office/drawing/2014/main" id="{9A97C86A-04D6-40F7-AE84-31AB43E6A846}"/>
@@ -6644,7 +6469,7 @@
       </p:sp>
       <p:sp>
         <p:nvSpPr>
-          <p:cNvPr id="18" name="Isosceles Triangle 17">
+          <p:cNvPr id="20" name="Isosceles Triangle 19">
             <a:extLst>
               <a:ext uri="{FF2B5EF4-FFF2-40B4-BE49-F238E27FC236}">
                 <a16:creationId xmlns:a16="http://schemas.microsoft.com/office/drawing/2014/main" id="{FF9F2414-84E8-453E-B1F3-389FDE8192D9}"/>
@@ -6709,10 +6534,10 @@
       </p:sp>
       <p:pic>
         <p:nvPicPr>
-          <p:cNvPr id="3" name="Imagen 2">
-            <a:extLst>
-              <a:ext uri="{FF2B5EF4-FFF2-40B4-BE49-F238E27FC236}">
-                <a16:creationId xmlns:a16="http://schemas.microsoft.com/office/drawing/2014/main" id="{D4DC2637-03D8-4333-9C22-7F14B6F6C0EE}"/>
+          <p:cNvPr id="5" name="Imagen 4">
+            <a:extLst>
+              <a:ext uri="{FF2B5EF4-FFF2-40B4-BE49-F238E27FC236}">
+                <a16:creationId xmlns:a16="http://schemas.microsoft.com/office/drawing/2014/main" id="{A8517BAD-3EC3-B1FB-9E67-BB587731E724}"/>
               </a:ext>
             </a:extLst>
           </p:cNvPr>
@@ -6735,8 +6560,8 @@
         </p:blipFill>
         <p:spPr>
           <a:xfrm>
-            <a:off x="1209100" y="643467"/>
-            <a:ext cx="9773799" cy="5571065"/>
+            <a:off x="643467" y="907203"/>
+            <a:ext cx="10905066" cy="5043592"/>
           </a:xfrm>
           <a:prstGeom prst="rect">
             <a:avLst/>
@@ -6748,7 +6573,7 @@
       </p:pic>
       <p:sp>
         <p:nvSpPr>
-          <p:cNvPr id="20" name="Isosceles Triangle 19">
+          <p:cNvPr id="22" name="Isosceles Triangle 21">
             <a:extLst>
               <a:ext uri="{FF2B5EF4-FFF2-40B4-BE49-F238E27FC236}">
                 <a16:creationId xmlns:a16="http://schemas.microsoft.com/office/drawing/2014/main" id="{3ECA69A1-7536-43AC-85EF-C7106179F5ED}"/>
@@ -6813,10 +6638,10 @@
       </p:sp>
       <p:sp>
         <p:nvSpPr>
-          <p:cNvPr id="5" name="CuadroTexto 4">
-            <a:extLst>
-              <a:ext uri="{FF2B5EF4-FFF2-40B4-BE49-F238E27FC236}">
-                <a16:creationId xmlns:a16="http://schemas.microsoft.com/office/drawing/2014/main" id="{B59B5114-929B-A9C9-0855-DA6D9F879AC3}"/>
+          <p:cNvPr id="13" name="CuadroTexto 12">
+            <a:extLst>
+              <a:ext uri="{FF2B5EF4-FFF2-40B4-BE49-F238E27FC236}">
+                <a16:creationId xmlns:a16="http://schemas.microsoft.com/office/drawing/2014/main" id="{A4D04D02-52A3-897F-783B-700822F77E93}"/>
               </a:ext>
             </a:extLst>
           </p:cNvPr>
@@ -6825,8 +6650,8 @@
         </p:nvSpPr>
         <p:spPr>
           <a:xfrm>
-            <a:off x="4633119" y="143427"/>
-            <a:ext cx="2925759" cy="369332"/>
+            <a:off x="4468218" y="250158"/>
+            <a:ext cx="3255564" cy="369332"/>
           </a:xfrm>
           <a:prstGeom prst="rect">
             <a:avLst/>
@@ -6865,15 +6690,111 @@
             <a:pPr algn="ctr"/>
             <a:r>
               <a:rPr lang="es-CO" b="1" dirty="0"/>
-              <a:t>Gestión de copropietarios</a:t>
+              <a:t>Aprende PAIC</a:t>
             </a:r>
           </a:p>
         </p:txBody>
       </p:sp>
+      <p:sp>
+        <p:nvSpPr>
+          <p:cNvPr id="6" name="CuadroTexto 5">
+            <a:extLst>
+              <a:ext uri="{FF2B5EF4-FFF2-40B4-BE49-F238E27FC236}">
+                <a16:creationId xmlns:a16="http://schemas.microsoft.com/office/drawing/2014/main" id="{6D4076C0-25EF-7C0A-D718-48B2EC777116}"/>
+              </a:ext>
+            </a:extLst>
+          </p:cNvPr>
+          <p:cNvSpPr txBox="1"/>
+          <p:nvPr/>
+        </p:nvSpPr>
+        <p:spPr>
+          <a:xfrm>
+            <a:off x="6915150" y="148117"/>
+            <a:ext cx="4267200" cy="646331"/>
+          </a:xfrm>
+          <a:prstGeom prst="rect">
+            <a:avLst/>
+          </a:prstGeom>
+          <a:solidFill>
+            <a:schemeClr val="accent2"/>
+          </a:solidFill>
+          <a:ln>
+            <a:noFill/>
+          </a:ln>
+        </p:spPr>
+        <p:style>
+          <a:lnRef idx="0">
+            <a:scrgbClr r="0" g="0" b="0"/>
+          </a:lnRef>
+          <a:fillRef idx="0">
+            <a:scrgbClr r="0" g="0" b="0"/>
+          </a:fillRef>
+          <a:effectRef idx="0">
+            <a:scrgbClr r="0" g="0" b="0"/>
+          </a:effectRef>
+          <a:fontRef idx="minor">
+            <a:schemeClr val="lt1"/>
+          </a:fontRef>
+        </p:style>
+        <p:txBody>
+          <a:bodyPr wrap="square" rtlCol="0">
+            <a:spAutoFit/>
+          </a:bodyPr>
+          <a:lstStyle/>
+          <a:p>
+            <a:pPr algn="ctr"/>
+            <a:r>
+              <a:rPr lang="es-CO" b="1" dirty="0"/>
+              <a:t>Ponte los audífonos y toma el tour guiado, te sorprenderá!</a:t>
+            </a:r>
+          </a:p>
+        </p:txBody>
+      </p:sp>
+      <p:cxnSp>
+        <p:nvCxnSpPr>
+          <p:cNvPr id="8" name="Conector recto de flecha 7">
+            <a:extLst>
+              <a:ext uri="{FF2B5EF4-FFF2-40B4-BE49-F238E27FC236}">
+                <a16:creationId xmlns:a16="http://schemas.microsoft.com/office/drawing/2014/main" id="{E9E99C5F-2D7A-075A-FC52-81DAC6527946}"/>
+              </a:ext>
+            </a:extLst>
+          </p:cNvPr>
+          <p:cNvCxnSpPr>
+            <a:cxnSpLocks/>
+          </p:cNvCxnSpPr>
+          <p:nvPr/>
+        </p:nvCxnSpPr>
+        <p:spPr>
+          <a:xfrm>
+            <a:off x="9161294" y="761796"/>
+            <a:ext cx="563731" cy="237080"/>
+          </a:xfrm>
+          <a:prstGeom prst="straightConnector1">
+            <a:avLst/>
+          </a:prstGeom>
+          <a:ln w="38100">
+            <a:tailEnd type="triangle"/>
+          </a:ln>
+        </p:spPr>
+        <p:style>
+          <a:lnRef idx="2">
+            <a:schemeClr val="accent2"/>
+          </a:lnRef>
+          <a:fillRef idx="0">
+            <a:schemeClr val="accent2"/>
+          </a:fillRef>
+          <a:effectRef idx="1">
+            <a:schemeClr val="accent2"/>
+          </a:effectRef>
+          <a:fontRef idx="minor">
+            <a:schemeClr val="tx1"/>
+          </a:fontRef>
+        </p:style>
+      </p:cxnSp>
     </p:spTree>
     <p:extLst>
       <p:ext uri="{BB962C8B-B14F-4D97-AF65-F5344CB8AC3E}">
-        <p14:creationId xmlns:p14="http://schemas.microsoft.com/office/powerpoint/2010/main" val="3946428088"/>
+        <p14:creationId xmlns:p14="http://schemas.microsoft.com/office/powerpoint/2010/main" val="4032973602"/>
       </p:ext>
     </p:extLst>
   </p:cSld>
@@ -6883,7 +6804,7 @@
 </p:sld>
 </file>
 
-<file path=ppt/slides/slide3.xml><?xml version="1.0" encoding="utf-8"?>
+<file path=ppt/slides/slide2.xml><?xml version="1.0" encoding="utf-8"?>
 <p:sld xmlns:a="http://schemas.openxmlformats.org/drawingml/2006/main" xmlns:r="http://schemas.openxmlformats.org/officeDocument/2006/relationships" xmlns:p="http://schemas.openxmlformats.org/presentationml/2006/main">
   <p:cSld>
     <p:bg>
@@ -7397,7 +7318,7 @@
           <p:cNvPr id="3" name="Imagen 2">
             <a:extLst>
               <a:ext uri="{FF2B5EF4-FFF2-40B4-BE49-F238E27FC236}">
-                <a16:creationId xmlns:a16="http://schemas.microsoft.com/office/drawing/2014/main" id="{874864DE-53A7-C456-DDE5-99FA5CA3C1D2}"/>
+                <a16:creationId xmlns:a16="http://schemas.microsoft.com/office/drawing/2014/main" id="{BDE039E2-8D9A-A968-78B0-40BC90031E73}"/>
               </a:ext>
             </a:extLst>
           </p:cNvPr>
@@ -7420,8 +7341,8 @@
         </p:blipFill>
         <p:spPr>
           <a:xfrm>
-            <a:off x="1293357" y="643467"/>
-            <a:ext cx="9605286" cy="5571065"/>
+            <a:off x="1187573" y="643467"/>
+            <a:ext cx="9816854" cy="5571065"/>
           </a:xfrm>
           <a:prstGeom prst="rect">
             <a:avLst/>
@@ -7498,10 +7419,10 @@
       </p:sp>
       <p:sp>
         <p:nvSpPr>
-          <p:cNvPr id="5" name="CuadroTexto 4">
-            <a:extLst>
-              <a:ext uri="{FF2B5EF4-FFF2-40B4-BE49-F238E27FC236}">
-                <a16:creationId xmlns:a16="http://schemas.microsoft.com/office/drawing/2014/main" id="{F6487998-4714-B39B-F78F-A11D0DB5D55E}"/>
+          <p:cNvPr id="4" name="CuadroTexto 3">
+            <a:extLst>
+              <a:ext uri="{FF2B5EF4-FFF2-40B4-BE49-F238E27FC236}">
+                <a16:creationId xmlns:a16="http://schemas.microsoft.com/office/drawing/2014/main" id="{CF798E75-5B85-AFF9-5448-E23C8AD18F35}"/>
               </a:ext>
             </a:extLst>
           </p:cNvPr>
@@ -7510,8 +7431,8 @@
         </p:nvSpPr>
         <p:spPr>
           <a:xfrm>
-            <a:off x="4583511" y="243969"/>
-            <a:ext cx="3024978" cy="369332"/>
+            <a:off x="4678321" y="133350"/>
+            <a:ext cx="2835357" cy="379409"/>
           </a:xfrm>
           <a:prstGeom prst="rect">
             <a:avLst/>
@@ -7550,7 +7471,7 @@
             <a:pPr algn="ctr"/>
             <a:r>
               <a:rPr lang="es-CO" b="1" dirty="0"/>
-              <a:t>Gestión de zonas comunes</a:t>
+              <a:t>Panel de control</a:t>
             </a:r>
           </a:p>
         </p:txBody>
@@ -7558,7 +7479,7 @@
     </p:spTree>
     <p:extLst>
       <p:ext uri="{BB962C8B-B14F-4D97-AF65-F5344CB8AC3E}">
-        <p14:creationId xmlns:p14="http://schemas.microsoft.com/office/powerpoint/2010/main" val="3312429141"/>
+        <p14:creationId xmlns:p14="http://schemas.microsoft.com/office/powerpoint/2010/main" val="3376057791"/>
       </p:ext>
     </p:extLst>
   </p:cSld>
@@ -7568,7 +7489,7 @@
 </p:sld>
 </file>
 
-<file path=ppt/slides/slide4.xml><?xml version="1.0" encoding="utf-8"?>
+<file path=ppt/slides/slide3.xml><?xml version="1.0" encoding="utf-8"?>
 <p:sld xmlns:a="http://schemas.openxmlformats.org/drawingml/2006/main" xmlns:r="http://schemas.openxmlformats.org/officeDocument/2006/relationships" xmlns:p="http://schemas.openxmlformats.org/presentationml/2006/main">
   <p:cSld>
     <p:bg>
@@ -8082,7 +8003,7 @@
           <p:cNvPr id="3" name="Imagen 2">
             <a:extLst>
               <a:ext uri="{FF2B5EF4-FFF2-40B4-BE49-F238E27FC236}">
-                <a16:creationId xmlns:a16="http://schemas.microsoft.com/office/drawing/2014/main" id="{1A393796-752C-FAB2-A8C7-C36F6F023FE1}"/>
+                <a16:creationId xmlns:a16="http://schemas.microsoft.com/office/drawing/2014/main" id="{D4DC2637-03D8-4333-9C22-7F14B6F6C0EE}"/>
               </a:ext>
             </a:extLst>
           </p:cNvPr>
@@ -8105,8 +8026,8 @@
         </p:blipFill>
         <p:spPr>
           <a:xfrm>
-            <a:off x="643467" y="879940"/>
-            <a:ext cx="10905066" cy="5098119"/>
+            <a:off x="1209100" y="643467"/>
+            <a:ext cx="9773799" cy="5571065"/>
           </a:xfrm>
           <a:prstGeom prst="rect">
             <a:avLst/>
@@ -8186,7 +8107,7 @@
           <p:cNvPr id="5" name="CuadroTexto 4">
             <a:extLst>
               <a:ext uri="{FF2B5EF4-FFF2-40B4-BE49-F238E27FC236}">
-                <a16:creationId xmlns:a16="http://schemas.microsoft.com/office/drawing/2014/main" id="{DF6A1CDB-C937-7345-A04C-48677A9A1682}"/>
+                <a16:creationId xmlns:a16="http://schemas.microsoft.com/office/drawing/2014/main" id="{B59B5114-929B-A9C9-0855-DA6D9F879AC3}"/>
               </a:ext>
             </a:extLst>
           </p:cNvPr>
@@ -8195,8 +8116,8 @@
         </p:nvSpPr>
         <p:spPr>
           <a:xfrm>
-            <a:off x="4583511" y="243969"/>
-            <a:ext cx="3024978" cy="369332"/>
+            <a:off x="4633119" y="143427"/>
+            <a:ext cx="2925759" cy="369332"/>
           </a:xfrm>
           <a:prstGeom prst="rect">
             <a:avLst/>
@@ -8235,7 +8156,7 @@
             <a:pPr algn="ctr"/>
             <a:r>
               <a:rPr lang="es-CO" b="1" dirty="0"/>
-              <a:t>Gestión Comunicaciones</a:t>
+              <a:t>Gestión de copropietarios</a:t>
             </a:r>
           </a:p>
         </p:txBody>
@@ -8243,7 +8164,7 @@
     </p:spTree>
     <p:extLst>
       <p:ext uri="{BB962C8B-B14F-4D97-AF65-F5344CB8AC3E}">
-        <p14:creationId xmlns:p14="http://schemas.microsoft.com/office/powerpoint/2010/main" val="3754545502"/>
+        <p14:creationId xmlns:p14="http://schemas.microsoft.com/office/powerpoint/2010/main" val="3946428088"/>
       </p:ext>
     </p:extLst>
   </p:cSld>
@@ -8253,7 +8174,7 @@
 </p:sld>
 </file>
 
-<file path=ppt/slides/slide5.xml><?xml version="1.0" encoding="utf-8"?>
+<file path=ppt/slides/slide4.xml><?xml version="1.0" encoding="utf-8"?>
 <p:sld xmlns:a="http://schemas.openxmlformats.org/drawingml/2006/main" xmlns:r="http://schemas.openxmlformats.org/officeDocument/2006/relationships" xmlns:p="http://schemas.openxmlformats.org/presentationml/2006/main">
   <p:cSld>
     <p:bg>
@@ -8767,7 +8688,7 @@
           <p:cNvPr id="3" name="Imagen 2">
             <a:extLst>
               <a:ext uri="{FF2B5EF4-FFF2-40B4-BE49-F238E27FC236}">
-                <a16:creationId xmlns:a16="http://schemas.microsoft.com/office/drawing/2014/main" id="{FBD6F30F-9C76-F707-C0C7-DCB96ABAB4D4}"/>
+                <a16:creationId xmlns:a16="http://schemas.microsoft.com/office/drawing/2014/main" id="{874864DE-53A7-C456-DDE5-99FA5CA3C1D2}"/>
               </a:ext>
             </a:extLst>
           </p:cNvPr>
@@ -8790,8 +8711,8 @@
         </p:blipFill>
         <p:spPr>
           <a:xfrm>
-            <a:off x="643467" y="2093129"/>
-            <a:ext cx="10905066" cy="2671740"/>
+            <a:off x="1293357" y="643467"/>
+            <a:ext cx="9605286" cy="5571065"/>
           </a:xfrm>
           <a:prstGeom prst="rect">
             <a:avLst/>
@@ -8871,7 +8792,7 @@
           <p:cNvPr id="5" name="CuadroTexto 4">
             <a:extLst>
               <a:ext uri="{FF2B5EF4-FFF2-40B4-BE49-F238E27FC236}">
-                <a16:creationId xmlns:a16="http://schemas.microsoft.com/office/drawing/2014/main" id="{8CC2D895-53A7-A1A5-E175-26D476791952}"/>
+                <a16:creationId xmlns:a16="http://schemas.microsoft.com/office/drawing/2014/main" id="{F6487998-4714-B39B-F78F-A11D0DB5D55E}"/>
               </a:ext>
             </a:extLst>
           </p:cNvPr>
@@ -8920,7 +8841,7 @@
             <a:pPr algn="ctr"/>
             <a:r>
               <a:rPr lang="es-CO" b="1" dirty="0"/>
-              <a:t>Gestión Documental</a:t>
+              <a:t>Gestión de zonas comunes</a:t>
             </a:r>
           </a:p>
         </p:txBody>
@@ -8928,7 +8849,7 @@
     </p:spTree>
     <p:extLst>
       <p:ext uri="{BB962C8B-B14F-4D97-AF65-F5344CB8AC3E}">
-        <p14:creationId xmlns:p14="http://schemas.microsoft.com/office/powerpoint/2010/main" val="2806888958"/>
+        <p14:creationId xmlns:p14="http://schemas.microsoft.com/office/powerpoint/2010/main" val="3312429141"/>
       </p:ext>
     </p:extLst>
   </p:cSld>
@@ -8938,7 +8859,7 @@
 </p:sld>
 </file>
 
-<file path=ppt/slides/slide6.xml><?xml version="1.0" encoding="utf-8"?>
+<file path=ppt/slides/slide5.xml><?xml version="1.0" encoding="utf-8"?>
 <p:sld xmlns:a="http://schemas.openxmlformats.org/drawingml/2006/main" xmlns:r="http://schemas.openxmlformats.org/officeDocument/2006/relationships" xmlns:p="http://schemas.openxmlformats.org/presentationml/2006/main">
   <p:cSld>
     <p:bg>
@@ -9452,7 +9373,7 @@
           <p:cNvPr id="3" name="Imagen 2">
             <a:extLst>
               <a:ext uri="{FF2B5EF4-FFF2-40B4-BE49-F238E27FC236}">
-                <a16:creationId xmlns:a16="http://schemas.microsoft.com/office/drawing/2014/main" id="{5F11DC1D-AE77-2E90-73CF-3177B74B07C0}"/>
+                <a16:creationId xmlns:a16="http://schemas.microsoft.com/office/drawing/2014/main" id="{1A393796-752C-FAB2-A8C7-C36F6F023FE1}"/>
               </a:ext>
             </a:extLst>
           </p:cNvPr>
@@ -9475,8 +9396,8 @@
         </p:blipFill>
         <p:spPr>
           <a:xfrm>
-            <a:off x="643467" y="1111673"/>
-            <a:ext cx="10905066" cy="4634652"/>
+            <a:off x="643467" y="879940"/>
+            <a:ext cx="10905066" cy="5098119"/>
           </a:xfrm>
           <a:prstGeom prst="rect">
             <a:avLst/>
@@ -9556,7 +9477,7 @@
           <p:cNvPr id="5" name="CuadroTexto 4">
             <a:extLst>
               <a:ext uri="{FF2B5EF4-FFF2-40B4-BE49-F238E27FC236}">
-                <a16:creationId xmlns:a16="http://schemas.microsoft.com/office/drawing/2014/main" id="{8BB328EB-E593-6FF2-1561-B15D51EDBFD9}"/>
+                <a16:creationId xmlns:a16="http://schemas.microsoft.com/office/drawing/2014/main" id="{DF6A1CDB-C937-7345-A04C-48677A9A1682}"/>
               </a:ext>
             </a:extLst>
           </p:cNvPr>
@@ -9605,7 +9526,7 @@
             <a:pPr algn="ctr"/>
             <a:r>
               <a:rPr lang="es-CO" b="1" dirty="0"/>
-              <a:t>Gestión Financiera</a:t>
+              <a:t>Gestión Comunicaciones</a:t>
             </a:r>
           </a:p>
         </p:txBody>
@@ -9613,7 +9534,7 @@
     </p:spTree>
     <p:extLst>
       <p:ext uri="{BB962C8B-B14F-4D97-AF65-F5344CB8AC3E}">
-        <p14:creationId xmlns:p14="http://schemas.microsoft.com/office/powerpoint/2010/main" val="2729674790"/>
+        <p14:creationId xmlns:p14="http://schemas.microsoft.com/office/powerpoint/2010/main" val="3754545502"/>
       </p:ext>
     </p:extLst>
   </p:cSld>
@@ -9623,7 +9544,7 @@
 </p:sld>
 </file>
 
-<file path=ppt/slides/slide7.xml><?xml version="1.0" encoding="utf-8"?>
+<file path=ppt/slides/slide6.xml><?xml version="1.0" encoding="utf-8"?>
 <p:sld xmlns:a="http://schemas.openxmlformats.org/drawingml/2006/main" xmlns:r="http://schemas.openxmlformats.org/officeDocument/2006/relationships" xmlns:p="http://schemas.openxmlformats.org/presentationml/2006/main">
   <p:cSld>
     <p:bg>
@@ -10137,7 +10058,7 @@
           <p:cNvPr id="3" name="Imagen 2">
             <a:extLst>
               <a:ext uri="{FF2B5EF4-FFF2-40B4-BE49-F238E27FC236}">
-                <a16:creationId xmlns:a16="http://schemas.microsoft.com/office/drawing/2014/main" id="{45E13F00-87E5-4E76-A3A9-5759E44E3221}"/>
+                <a16:creationId xmlns:a16="http://schemas.microsoft.com/office/drawing/2014/main" id="{FBD6F30F-9C76-F707-C0C7-DCB96ABAB4D4}"/>
               </a:ext>
             </a:extLst>
           </p:cNvPr>
@@ -10160,8 +10081,8 @@
         </p:blipFill>
         <p:spPr>
           <a:xfrm>
-            <a:off x="643467" y="1343406"/>
-            <a:ext cx="10905066" cy="4171186"/>
+            <a:off x="643467" y="2093129"/>
+            <a:ext cx="10905066" cy="2671740"/>
           </a:xfrm>
           <a:prstGeom prst="rect">
             <a:avLst/>
@@ -10241,7 +10162,7 @@
           <p:cNvPr id="5" name="CuadroTexto 4">
             <a:extLst>
               <a:ext uri="{FF2B5EF4-FFF2-40B4-BE49-F238E27FC236}">
-                <a16:creationId xmlns:a16="http://schemas.microsoft.com/office/drawing/2014/main" id="{EEFC2C80-5DBF-C502-94E8-64294C5FC3CD}"/>
+                <a16:creationId xmlns:a16="http://schemas.microsoft.com/office/drawing/2014/main" id="{8CC2D895-53A7-A1A5-E175-26D476791952}"/>
               </a:ext>
             </a:extLst>
           </p:cNvPr>
@@ -10250,8 +10171,8 @@
         </p:nvSpPr>
         <p:spPr>
           <a:xfrm>
-            <a:off x="4468218" y="250158"/>
-            <a:ext cx="3255564" cy="369332"/>
+            <a:off x="4583511" y="243969"/>
+            <a:ext cx="3024978" cy="369332"/>
           </a:xfrm>
           <a:prstGeom prst="rect">
             <a:avLst/>
@@ -10290,7 +10211,7 @@
             <a:pPr algn="ctr"/>
             <a:r>
               <a:rPr lang="es-CO" b="1" dirty="0"/>
-              <a:t>Gestión de visitas y paquetes</a:t>
+              <a:t>Gestión Documental</a:t>
             </a:r>
           </a:p>
         </p:txBody>
@@ -10298,7 +10219,7 @@
     </p:spTree>
     <p:extLst>
       <p:ext uri="{BB962C8B-B14F-4D97-AF65-F5344CB8AC3E}">
-        <p14:creationId xmlns:p14="http://schemas.microsoft.com/office/powerpoint/2010/main" val="412010969"/>
+        <p14:creationId xmlns:p14="http://schemas.microsoft.com/office/powerpoint/2010/main" val="2806888958"/>
       </p:ext>
     </p:extLst>
   </p:cSld>
@@ -10308,7 +10229,7 @@
 </p:sld>
 </file>
 
-<file path=ppt/slides/slide8.xml><?xml version="1.0" encoding="utf-8"?>
+<file path=ppt/slides/slide7.xml><?xml version="1.0" encoding="utf-8"?>
 <p:sld xmlns:a="http://schemas.openxmlformats.org/drawingml/2006/main" xmlns:r="http://schemas.openxmlformats.org/officeDocument/2006/relationships" xmlns:p="http://schemas.openxmlformats.org/presentationml/2006/main">
   <p:cSld>
     <p:bg>
@@ -10822,7 +10743,7 @@
           <p:cNvPr id="3" name="Imagen 2">
             <a:extLst>
               <a:ext uri="{FF2B5EF4-FFF2-40B4-BE49-F238E27FC236}">
-                <a16:creationId xmlns:a16="http://schemas.microsoft.com/office/drawing/2014/main" id="{10439659-C619-B1BC-7A61-09A890FD605F}"/>
+                <a16:creationId xmlns:a16="http://schemas.microsoft.com/office/drawing/2014/main" id="{5F11DC1D-AE77-2E90-73CF-3177B74B07C0}"/>
               </a:ext>
             </a:extLst>
           </p:cNvPr>
@@ -10845,8 +10766,8 @@
         </p:blipFill>
         <p:spPr>
           <a:xfrm>
-            <a:off x="643467" y="1520613"/>
-            <a:ext cx="10905066" cy="3816772"/>
+            <a:off x="643467" y="1111673"/>
+            <a:ext cx="10905066" cy="4634652"/>
           </a:xfrm>
           <a:prstGeom prst="rect">
             <a:avLst/>
@@ -10926,7 +10847,7 @@
           <p:cNvPr id="5" name="CuadroTexto 4">
             <a:extLst>
               <a:ext uri="{FF2B5EF4-FFF2-40B4-BE49-F238E27FC236}">
-                <a16:creationId xmlns:a16="http://schemas.microsoft.com/office/drawing/2014/main" id="{A2619C58-CA1A-0779-DCDF-63269017A7D0}"/>
+                <a16:creationId xmlns:a16="http://schemas.microsoft.com/office/drawing/2014/main" id="{8BB328EB-E593-6FF2-1561-B15D51EDBFD9}"/>
               </a:ext>
             </a:extLst>
           </p:cNvPr>
@@ -10935,8 +10856,8 @@
         </p:nvSpPr>
         <p:spPr>
           <a:xfrm>
-            <a:off x="4468218" y="250158"/>
-            <a:ext cx="3255564" cy="369332"/>
+            <a:off x="4583511" y="243969"/>
+            <a:ext cx="3024978" cy="369332"/>
           </a:xfrm>
           <a:prstGeom prst="rect">
             <a:avLst/>
@@ -10975,20 +10896,15 @@
             <a:pPr algn="ctr"/>
             <a:r>
               <a:rPr lang="es-CO" b="1" dirty="0"/>
-              <a:t>Gestión de </a:t>
+              <a:t>Gestión Financiera</a:t>
             </a:r>
-            <a:r>
-              <a:rPr lang="es-CO" b="1" dirty="0" err="1"/>
-              <a:t>Vecimientos</a:t>
-            </a:r>
-            <a:endParaRPr lang="es-CO" b="1" dirty="0"/>
           </a:p>
         </p:txBody>
       </p:sp>
     </p:spTree>
     <p:extLst>
       <p:ext uri="{BB962C8B-B14F-4D97-AF65-F5344CB8AC3E}">
-        <p14:creationId xmlns:p14="http://schemas.microsoft.com/office/powerpoint/2010/main" val="843671556"/>
+        <p14:creationId xmlns:p14="http://schemas.microsoft.com/office/powerpoint/2010/main" val="2729674790"/>
       </p:ext>
     </p:extLst>
   </p:cSld>
@@ -10998,7 +10914,7 @@
 </p:sld>
 </file>
 
-<file path=ppt/slides/slide9.xml><?xml version="1.0" encoding="utf-8"?>
+<file path=ppt/slides/slide8.xml><?xml version="1.0" encoding="utf-8"?>
 <p:sld xmlns:a="http://schemas.openxmlformats.org/drawingml/2006/main" xmlns:r="http://schemas.openxmlformats.org/officeDocument/2006/relationships" xmlns:p="http://schemas.openxmlformats.org/presentationml/2006/main">
   <p:cSld>
     <p:bg>
@@ -11512,7 +11428,7 @@
           <p:cNvPr id="3" name="Imagen 2">
             <a:extLst>
               <a:ext uri="{FF2B5EF4-FFF2-40B4-BE49-F238E27FC236}">
-                <a16:creationId xmlns:a16="http://schemas.microsoft.com/office/drawing/2014/main" id="{4E0CFFBE-8F93-5A2A-3593-8B1C2315A87F}"/>
+                <a16:creationId xmlns:a16="http://schemas.microsoft.com/office/drawing/2014/main" id="{45E13F00-87E5-4E76-A3A9-5759E44E3221}"/>
               </a:ext>
             </a:extLst>
           </p:cNvPr>
@@ -11535,8 +11451,8 @@
         </p:blipFill>
         <p:spPr>
           <a:xfrm>
-            <a:off x="643467" y="1861396"/>
-            <a:ext cx="10905066" cy="3135206"/>
+            <a:off x="643467" y="1343406"/>
+            <a:ext cx="10905066" cy="4171186"/>
           </a:xfrm>
           <a:prstGeom prst="rect">
             <a:avLst/>
@@ -11616,7 +11532,7 @@
           <p:cNvPr id="5" name="CuadroTexto 4">
             <a:extLst>
               <a:ext uri="{FF2B5EF4-FFF2-40B4-BE49-F238E27FC236}">
-                <a16:creationId xmlns:a16="http://schemas.microsoft.com/office/drawing/2014/main" id="{1AA30F0F-F6BA-0152-7664-46AB10BB2E08}"/>
+                <a16:creationId xmlns:a16="http://schemas.microsoft.com/office/drawing/2014/main" id="{EEFC2C80-5DBF-C502-94E8-64294C5FC3CD}"/>
               </a:ext>
             </a:extLst>
           </p:cNvPr>
@@ -11665,7 +11581,7 @@
             <a:pPr algn="ctr"/>
             <a:r>
               <a:rPr lang="es-CO" b="1" dirty="0"/>
-              <a:t>Gestión de tareas</a:t>
+              <a:t>Gestión de visitas y paquetes</a:t>
             </a:r>
           </a:p>
         </p:txBody>
@@ -11673,7 +11589,697 @@
     </p:spTree>
     <p:extLst>
       <p:ext uri="{BB962C8B-B14F-4D97-AF65-F5344CB8AC3E}">
-        <p14:creationId xmlns:p14="http://schemas.microsoft.com/office/powerpoint/2010/main" val="4068809485"/>
+        <p14:creationId xmlns:p14="http://schemas.microsoft.com/office/powerpoint/2010/main" val="412010969"/>
+      </p:ext>
+    </p:extLst>
+  </p:cSld>
+  <p:clrMapOvr>
+    <a:masterClrMapping/>
+  </p:clrMapOvr>
+</p:sld>
+</file>
+
+<file path=ppt/slides/slide9.xml><?xml version="1.0" encoding="utf-8"?>
+<p:sld xmlns:a="http://schemas.openxmlformats.org/drawingml/2006/main" xmlns:r="http://schemas.openxmlformats.org/officeDocument/2006/relationships" xmlns:p="http://schemas.openxmlformats.org/presentationml/2006/main">
+  <p:cSld>
+    <p:bg>
+      <p:bgPr>
+        <a:solidFill>
+          <a:schemeClr val="bg1"/>
+        </a:solidFill>
+        <a:effectLst/>
+      </p:bgPr>
+    </p:bg>
+    <p:spTree>
+      <p:nvGrpSpPr>
+        <p:cNvPr id="1" name=""/>
+        <p:cNvGrpSpPr/>
+        <p:nvPr/>
+      </p:nvGrpSpPr>
+      <p:grpSpPr>
+        <a:xfrm>
+          <a:off x="0" y="0"/>
+          <a:ext cx="0" cy="0"/>
+          <a:chOff x="0" y="0"/>
+          <a:chExt cx="0" cy="0"/>
+        </a:xfrm>
+      </p:grpSpPr>
+      <p:sp>
+        <p:nvSpPr>
+          <p:cNvPr id="8" name="Rectangle 7">
+            <a:extLst>
+              <a:ext uri="{FF2B5EF4-FFF2-40B4-BE49-F238E27FC236}">
+                <a16:creationId xmlns:a16="http://schemas.microsoft.com/office/drawing/2014/main" id="{F3060C83-F051-4F0E-ABAD-AA0DFC48B218}"/>
+              </a:ext>
+              <a:ext uri="{C183D7F6-B498-43B3-948B-1728B52AA6E4}">
+                <adec:decorative xmlns:adec="http://schemas.microsoft.com/office/drawing/2017/decorative" val="1"/>
+              </a:ext>
+            </a:extLst>
+          </p:cNvPr>
+          <p:cNvSpPr>
+            <a:spLocks noGrp="1" noRot="1" noChangeAspect="1" noMove="1" noResize="1" noEditPoints="1" noAdjustHandles="1" noChangeArrowheads="1" noChangeShapeType="1" noTextEdit="1"/>
+          </p:cNvSpPr>
+          <p:nvPr>
+            <p:extLst>
+              <p:ext uri="{386F3935-93C4-4BCD-93E2-E3B085C9AB24}">
+                <p16:designElem xmlns:p16="http://schemas.microsoft.com/office/powerpoint/2015/main" val="1"/>
+              </p:ext>
+            </p:extLst>
+          </p:nvPr>
+        </p:nvSpPr>
+        <p:spPr>
+          <a:xfrm>
+            <a:off x="0" y="0"/>
+            <a:ext cx="12192000" cy="6858000"/>
+          </a:xfrm>
+          <a:prstGeom prst="rect">
+            <a:avLst/>
+          </a:prstGeom>
+          <a:solidFill>
+            <a:schemeClr val="bg1"/>
+          </a:solidFill>
+          <a:ln>
+            <a:noFill/>
+          </a:ln>
+        </p:spPr>
+        <p:style>
+          <a:lnRef idx="2">
+            <a:schemeClr val="accent1">
+              <a:shade val="50000"/>
+            </a:schemeClr>
+          </a:lnRef>
+          <a:fillRef idx="1">
+            <a:schemeClr val="accent1"/>
+          </a:fillRef>
+          <a:effectRef idx="0">
+            <a:schemeClr val="accent1"/>
+          </a:effectRef>
+          <a:fontRef idx="minor">
+            <a:schemeClr val="lt1"/>
+          </a:fontRef>
+        </p:style>
+        <p:txBody>
+          <a:bodyPr rtlCol="0" anchor="ctr"/>
+          <a:lstStyle/>
+          <a:p>
+            <a:pPr algn="ctr"/>
+            <a:endParaRPr lang="en-US" dirty="0"/>
+          </a:p>
+        </p:txBody>
+      </p:sp>
+      <p:sp>
+        <p:nvSpPr>
+          <p:cNvPr id="10" name="Freeform: Shape 9">
+            <a:extLst>
+              <a:ext uri="{FF2B5EF4-FFF2-40B4-BE49-F238E27FC236}">
+                <a16:creationId xmlns:a16="http://schemas.microsoft.com/office/drawing/2014/main" id="{83C98ABE-055B-441F-B07E-44F97F083C39}"/>
+              </a:ext>
+              <a:ext uri="{C183D7F6-B498-43B3-948B-1728B52AA6E4}">
+                <adec:decorative xmlns:adec="http://schemas.microsoft.com/office/drawing/2017/decorative" val="1"/>
+              </a:ext>
+            </a:extLst>
+          </p:cNvPr>
+          <p:cNvSpPr>
+            <a:spLocks noGrp="1" noRot="1" noChangeAspect="1" noMove="1" noResize="1" noEditPoints="1" noAdjustHandles="1" noChangeArrowheads="1" noChangeShapeType="1" noTextEdit="1"/>
+          </p:cNvSpPr>
+          <p:nvPr>
+            <p:extLst>
+              <p:ext uri="{386F3935-93C4-4BCD-93E2-E3B085C9AB24}">
+                <p16:designElem xmlns:p16="http://schemas.microsoft.com/office/powerpoint/2015/main" val="1"/>
+              </p:ext>
+            </p:extLst>
+          </p:nvPr>
+        </p:nvSpPr>
+        <p:spPr>
+          <a:xfrm rot="18900000" flipH="1">
+            <a:off x="-376156" y="-253670"/>
+            <a:ext cx="1827638" cy="1376989"/>
+          </a:xfrm>
+          <a:custGeom>
+            <a:avLst/>
+            <a:gdLst>
+              <a:gd name="connsiteX0" fmla="*/ 0 w 1827638"/>
+              <a:gd name="connsiteY0" fmla="*/ 987379 h 1376989"/>
+              <a:gd name="connsiteX1" fmla="*/ 987379 w 1827638"/>
+              <a:gd name="connsiteY1" fmla="*/ 0 h 1376989"/>
+              <a:gd name="connsiteX2" fmla="*/ 1827638 w 1827638"/>
+              <a:gd name="connsiteY2" fmla="*/ 840260 h 1376989"/>
+              <a:gd name="connsiteX3" fmla="*/ 1827638 w 1827638"/>
+              <a:gd name="connsiteY3" fmla="*/ 1376989 h 1376989"/>
+              <a:gd name="connsiteX4" fmla="*/ 0 w 1827638"/>
+              <a:gd name="connsiteY4" fmla="*/ 1376989 h 1376989"/>
+            </a:gdLst>
+            <a:ahLst/>
+            <a:cxnLst>
+              <a:cxn ang="0">
+                <a:pos x="connsiteX0" y="connsiteY0"/>
+              </a:cxn>
+              <a:cxn ang="0">
+                <a:pos x="connsiteX1" y="connsiteY1"/>
+              </a:cxn>
+              <a:cxn ang="0">
+                <a:pos x="connsiteX2" y="connsiteY2"/>
+              </a:cxn>
+              <a:cxn ang="0">
+                <a:pos x="connsiteX3" y="connsiteY3"/>
+              </a:cxn>
+              <a:cxn ang="0">
+                <a:pos x="connsiteX4" y="connsiteY4"/>
+              </a:cxn>
+            </a:cxnLst>
+            <a:rect l="l" t="t" r="r" b="b"/>
+            <a:pathLst>
+              <a:path w="1827638" h="1376989">
+                <a:moveTo>
+                  <a:pt x="0" y="987379"/>
+                </a:moveTo>
+                <a:lnTo>
+                  <a:pt x="987379" y="0"/>
+                </a:lnTo>
+                <a:lnTo>
+                  <a:pt x="1827638" y="840260"/>
+                </a:lnTo>
+                <a:lnTo>
+                  <a:pt x="1827638" y="1376989"/>
+                </a:lnTo>
+                <a:lnTo>
+                  <a:pt x="0" y="1376989"/>
+                </a:lnTo>
+                <a:close/>
+              </a:path>
+            </a:pathLst>
+          </a:custGeom>
+          <a:solidFill>
+            <a:schemeClr val="accent1">
+              <a:alpha val="30000"/>
+            </a:schemeClr>
+          </a:solidFill>
+          <a:ln>
+            <a:noFill/>
+          </a:ln>
+        </p:spPr>
+        <p:style>
+          <a:lnRef idx="2">
+            <a:schemeClr val="accent1">
+              <a:shade val="50000"/>
+            </a:schemeClr>
+          </a:lnRef>
+          <a:fillRef idx="1">
+            <a:schemeClr val="accent1"/>
+          </a:fillRef>
+          <a:effectRef idx="0">
+            <a:schemeClr val="accent1"/>
+          </a:effectRef>
+          <a:fontRef idx="minor">
+            <a:schemeClr val="lt1"/>
+          </a:fontRef>
+        </p:style>
+        <p:txBody>
+          <a:bodyPr rtlCol="0" anchor="ctr"/>
+          <a:lstStyle/>
+          <a:p>
+            <a:pPr algn="ctr"/>
+            <a:endParaRPr lang="en-US" dirty="0"/>
+          </a:p>
+        </p:txBody>
+      </p:sp>
+      <p:sp>
+        <p:nvSpPr>
+          <p:cNvPr id="12" name="Rectangle 11">
+            <a:extLst>
+              <a:ext uri="{FF2B5EF4-FFF2-40B4-BE49-F238E27FC236}">
+                <a16:creationId xmlns:a16="http://schemas.microsoft.com/office/drawing/2014/main" id="{29FDB030-9B49-4CED-8CCD-4D99382388AC}"/>
+              </a:ext>
+              <a:ext uri="{C183D7F6-B498-43B3-948B-1728B52AA6E4}">
+                <adec:decorative xmlns:adec="http://schemas.microsoft.com/office/drawing/2017/decorative" val="1"/>
+              </a:ext>
+            </a:extLst>
+          </p:cNvPr>
+          <p:cNvSpPr>
+            <a:spLocks noGrp="1" noRot="1" noChangeAspect="1" noMove="1" noResize="1" noEditPoints="1" noAdjustHandles="1" noChangeArrowheads="1" noChangeShapeType="1" noTextEdit="1"/>
+          </p:cNvSpPr>
+          <p:nvPr>
+            <p:extLst>
+              <p:ext uri="{386F3935-93C4-4BCD-93E2-E3B085C9AB24}">
+                <p16:designElem xmlns:p16="http://schemas.microsoft.com/office/powerpoint/2015/main" val="1"/>
+              </p:ext>
+            </p:extLst>
+          </p:nvPr>
+        </p:nvSpPr>
+        <p:spPr>
+          <a:xfrm rot="18900000" flipH="1">
+            <a:off x="891641" y="422146"/>
+            <a:ext cx="645368" cy="645368"/>
+          </a:xfrm>
+          <a:prstGeom prst="rect">
+            <a:avLst/>
+          </a:prstGeom>
+          <a:solidFill>
+            <a:schemeClr val="accent1">
+              <a:alpha val="30000"/>
+            </a:schemeClr>
+          </a:solidFill>
+          <a:ln>
+            <a:noFill/>
+          </a:ln>
+        </p:spPr>
+        <p:style>
+          <a:lnRef idx="2">
+            <a:schemeClr val="accent1">
+              <a:shade val="50000"/>
+            </a:schemeClr>
+          </a:lnRef>
+          <a:fillRef idx="1">
+            <a:schemeClr val="accent1"/>
+          </a:fillRef>
+          <a:effectRef idx="0">
+            <a:schemeClr val="accent1"/>
+          </a:effectRef>
+          <a:fontRef idx="minor">
+            <a:schemeClr val="lt1"/>
+          </a:fontRef>
+        </p:style>
+        <p:txBody>
+          <a:bodyPr rtlCol="0" anchor="ctr"/>
+          <a:lstStyle/>
+          <a:p>
+            <a:pPr algn="ctr"/>
+            <a:endParaRPr lang="en-US"/>
+          </a:p>
+        </p:txBody>
+      </p:sp>
+      <p:sp>
+        <p:nvSpPr>
+          <p:cNvPr id="14" name="Rectangle 13">
+            <a:extLst>
+              <a:ext uri="{FF2B5EF4-FFF2-40B4-BE49-F238E27FC236}">
+                <a16:creationId xmlns:a16="http://schemas.microsoft.com/office/drawing/2014/main" id="{3783CA14-24A1-485C-8B30-D6A5D87987AD}"/>
+              </a:ext>
+              <a:ext uri="{C183D7F6-B498-43B3-948B-1728B52AA6E4}">
+                <adec:decorative xmlns:adec="http://schemas.microsoft.com/office/drawing/2017/decorative" val="1"/>
+              </a:ext>
+            </a:extLst>
+          </p:cNvPr>
+          <p:cNvSpPr>
+            <a:spLocks noGrp="1" noRot="1" noChangeAspect="1" noMove="1" noResize="1" noEditPoints="1" noAdjustHandles="1" noChangeArrowheads="1" noChangeShapeType="1" noTextEdit="1"/>
+          </p:cNvSpPr>
+          <p:nvPr>
+            <p:extLst>
+              <p:ext uri="{386F3935-93C4-4BCD-93E2-E3B085C9AB24}">
+                <p16:designElem xmlns:p16="http://schemas.microsoft.com/office/powerpoint/2015/main" val="1"/>
+              </p:ext>
+            </p:extLst>
+          </p:nvPr>
+        </p:nvSpPr>
+        <p:spPr>
+          <a:xfrm rot="18900000" flipH="1">
+            <a:off x="10043482" y="655140"/>
+            <a:ext cx="687472" cy="687472"/>
+          </a:xfrm>
+          <a:prstGeom prst="rect">
+            <a:avLst/>
+          </a:prstGeom>
+          <a:solidFill>
+            <a:schemeClr val="accent4">
+              <a:alpha val="30000"/>
+            </a:schemeClr>
+          </a:solidFill>
+          <a:ln>
+            <a:noFill/>
+          </a:ln>
+        </p:spPr>
+        <p:style>
+          <a:lnRef idx="2">
+            <a:schemeClr val="accent1">
+              <a:shade val="50000"/>
+            </a:schemeClr>
+          </a:lnRef>
+          <a:fillRef idx="1">
+            <a:schemeClr val="accent1"/>
+          </a:fillRef>
+          <a:effectRef idx="0">
+            <a:schemeClr val="accent1"/>
+          </a:effectRef>
+          <a:fontRef idx="minor">
+            <a:schemeClr val="lt1"/>
+          </a:fontRef>
+        </p:style>
+        <p:txBody>
+          <a:bodyPr rtlCol="0" anchor="ctr"/>
+          <a:lstStyle/>
+          <a:p>
+            <a:pPr algn="ctr"/>
+            <a:endParaRPr lang="en-US"/>
+          </a:p>
+        </p:txBody>
+      </p:sp>
+      <p:sp>
+        <p:nvSpPr>
+          <p:cNvPr id="16" name="Freeform: Shape 15">
+            <a:extLst>
+              <a:ext uri="{FF2B5EF4-FFF2-40B4-BE49-F238E27FC236}">
+                <a16:creationId xmlns:a16="http://schemas.microsoft.com/office/drawing/2014/main" id="{9A97C86A-04D6-40F7-AE84-31AB43E6A846}"/>
+              </a:ext>
+              <a:ext uri="{C183D7F6-B498-43B3-948B-1728B52AA6E4}">
+                <adec:decorative xmlns:adec="http://schemas.microsoft.com/office/drawing/2017/decorative" val="1"/>
+              </a:ext>
+            </a:extLst>
+          </p:cNvPr>
+          <p:cNvSpPr>
+            <a:spLocks noGrp="1" noRot="1" noChangeAspect="1" noMove="1" noResize="1" noEditPoints="1" noAdjustHandles="1" noChangeArrowheads="1" noChangeShapeType="1" noTextEdit="1"/>
+          </p:cNvSpPr>
+          <p:nvPr>
+            <p:extLst>
+              <p:ext uri="{386F3935-93C4-4BCD-93E2-E3B085C9AB24}">
+                <p16:designElem xmlns:p16="http://schemas.microsoft.com/office/powerpoint/2015/main" val="1"/>
+              </p:ext>
+            </p:extLst>
+          </p:nvPr>
+        </p:nvSpPr>
+        <p:spPr>
+          <a:xfrm rot="10800000" flipH="1">
+            <a:off x="9356643" y="0"/>
+            <a:ext cx="2835357" cy="1480837"/>
+          </a:xfrm>
+          <a:custGeom>
+            <a:avLst/>
+            <a:gdLst>
+              <a:gd name="connsiteX0" fmla="*/ 2835357 w 2835357"/>
+              <a:gd name="connsiteY0" fmla="*/ 1480837 h 1480837"/>
+              <a:gd name="connsiteX1" fmla="*/ 0 w 2835357"/>
+              <a:gd name="connsiteY1" fmla="*/ 1480837 h 1480837"/>
+              <a:gd name="connsiteX2" fmla="*/ 1552727 w 2835357"/>
+              <a:gd name="connsiteY2" fmla="*/ 0 h 1480837"/>
+              <a:gd name="connsiteX3" fmla="*/ 2835357 w 2835357"/>
+              <a:gd name="connsiteY3" fmla="*/ 1223245 h 1480837"/>
+            </a:gdLst>
+            <a:ahLst/>
+            <a:cxnLst>
+              <a:cxn ang="0">
+                <a:pos x="connsiteX0" y="connsiteY0"/>
+              </a:cxn>
+              <a:cxn ang="0">
+                <a:pos x="connsiteX1" y="connsiteY1"/>
+              </a:cxn>
+              <a:cxn ang="0">
+                <a:pos x="connsiteX2" y="connsiteY2"/>
+              </a:cxn>
+              <a:cxn ang="0">
+                <a:pos x="connsiteX3" y="connsiteY3"/>
+              </a:cxn>
+            </a:cxnLst>
+            <a:rect l="l" t="t" r="r" b="b"/>
+            <a:pathLst>
+              <a:path w="2835357" h="1480837">
+                <a:moveTo>
+                  <a:pt x="2835357" y="1480837"/>
+                </a:moveTo>
+                <a:lnTo>
+                  <a:pt x="0" y="1480837"/>
+                </a:lnTo>
+                <a:lnTo>
+                  <a:pt x="1552727" y="0"/>
+                </a:lnTo>
+                <a:lnTo>
+                  <a:pt x="2835357" y="1223245"/>
+                </a:lnTo>
+                <a:close/>
+              </a:path>
+            </a:pathLst>
+          </a:custGeom>
+          <a:solidFill>
+            <a:schemeClr val="accent4">
+              <a:alpha val="30000"/>
+            </a:schemeClr>
+          </a:solidFill>
+          <a:ln>
+            <a:noFill/>
+          </a:ln>
+        </p:spPr>
+        <p:style>
+          <a:lnRef idx="2">
+            <a:schemeClr val="accent1">
+              <a:shade val="50000"/>
+            </a:schemeClr>
+          </a:lnRef>
+          <a:fillRef idx="1">
+            <a:schemeClr val="accent1"/>
+          </a:fillRef>
+          <a:effectRef idx="0">
+            <a:schemeClr val="accent1"/>
+          </a:effectRef>
+          <a:fontRef idx="minor">
+            <a:schemeClr val="lt1"/>
+          </a:fontRef>
+        </p:style>
+        <p:txBody>
+          <a:bodyPr wrap="square" rtlCol="0" anchor="ctr">
+            <a:noAutofit/>
+          </a:bodyPr>
+          <a:lstStyle/>
+          <a:p>
+            <a:pPr algn="ctr"/>
+            <a:endParaRPr lang="en-US" dirty="0"/>
+          </a:p>
+        </p:txBody>
+      </p:sp>
+      <p:sp>
+        <p:nvSpPr>
+          <p:cNvPr id="18" name="Isosceles Triangle 17">
+            <a:extLst>
+              <a:ext uri="{FF2B5EF4-FFF2-40B4-BE49-F238E27FC236}">
+                <a16:creationId xmlns:a16="http://schemas.microsoft.com/office/drawing/2014/main" id="{FF9F2414-84E8-453E-B1F3-389FDE8192D9}"/>
+              </a:ext>
+              <a:ext uri="{C183D7F6-B498-43B3-948B-1728B52AA6E4}">
+                <adec:decorative xmlns:adec="http://schemas.microsoft.com/office/drawing/2017/decorative" val="1"/>
+              </a:ext>
+            </a:extLst>
+          </p:cNvPr>
+          <p:cNvSpPr>
+            <a:spLocks noGrp="1" noRot="1" noChangeAspect="1" noMove="1" noResize="1" noEditPoints="1" noAdjustHandles="1" noChangeArrowheads="1" noChangeShapeType="1" noTextEdit="1"/>
+          </p:cNvSpPr>
+          <p:nvPr>
+            <p:extLst>
+              <p:ext uri="{386F3935-93C4-4BCD-93E2-E3B085C9AB24}">
+                <p16:designElem xmlns:p16="http://schemas.microsoft.com/office/powerpoint/2015/main" val="1"/>
+              </p:ext>
+            </p:extLst>
+          </p:nvPr>
+        </p:nvSpPr>
+        <p:spPr>
+          <a:xfrm flipH="1">
+            <a:off x="7976344" y="6115501"/>
+            <a:ext cx="1494513" cy="742499"/>
+          </a:xfrm>
+          <a:prstGeom prst="triangle">
+            <a:avLst/>
+          </a:prstGeom>
+          <a:solidFill>
+            <a:schemeClr val="accent1">
+              <a:alpha val="30000"/>
+            </a:schemeClr>
+          </a:solidFill>
+          <a:ln>
+            <a:noFill/>
+          </a:ln>
+        </p:spPr>
+        <p:style>
+          <a:lnRef idx="2">
+            <a:schemeClr val="accent1">
+              <a:shade val="50000"/>
+            </a:schemeClr>
+          </a:lnRef>
+          <a:fillRef idx="1">
+            <a:schemeClr val="accent1"/>
+          </a:fillRef>
+          <a:effectRef idx="0">
+            <a:schemeClr val="accent1"/>
+          </a:effectRef>
+          <a:fontRef idx="minor">
+            <a:schemeClr val="lt1"/>
+          </a:fontRef>
+        </p:style>
+        <p:txBody>
+          <a:bodyPr rtlCol="0" anchor="ctr"/>
+          <a:lstStyle/>
+          <a:p>
+            <a:pPr algn="ctr"/>
+            <a:endParaRPr lang="en-US"/>
+          </a:p>
+        </p:txBody>
+      </p:sp>
+      <p:pic>
+        <p:nvPicPr>
+          <p:cNvPr id="3" name="Imagen 2">
+            <a:extLst>
+              <a:ext uri="{FF2B5EF4-FFF2-40B4-BE49-F238E27FC236}">
+                <a16:creationId xmlns:a16="http://schemas.microsoft.com/office/drawing/2014/main" id="{10439659-C619-B1BC-7A61-09A890FD605F}"/>
+              </a:ext>
+            </a:extLst>
+          </p:cNvPr>
+          <p:cNvPicPr>
+            <a:picLocks noChangeAspect="1"/>
+          </p:cNvPicPr>
+          <p:nvPr/>
+        </p:nvPicPr>
+        <p:blipFill>
+          <a:blip r:embed="rId2">
+            <a:extLst>
+              <a:ext uri="{28A0092B-C50C-407E-A947-70E740481C1C}">
+                <a14:useLocalDpi xmlns:a14="http://schemas.microsoft.com/office/drawing/2010/main" val="0"/>
+              </a:ext>
+            </a:extLst>
+          </a:blip>
+          <a:stretch>
+            <a:fillRect/>
+          </a:stretch>
+        </p:blipFill>
+        <p:spPr>
+          <a:xfrm>
+            <a:off x="643467" y="1520613"/>
+            <a:ext cx="10905066" cy="3816772"/>
+          </a:xfrm>
+          <a:prstGeom prst="rect">
+            <a:avLst/>
+          </a:prstGeom>
+          <a:ln>
+            <a:noFill/>
+          </a:ln>
+        </p:spPr>
+      </p:pic>
+      <p:sp>
+        <p:nvSpPr>
+          <p:cNvPr id="20" name="Isosceles Triangle 19">
+            <a:extLst>
+              <a:ext uri="{FF2B5EF4-FFF2-40B4-BE49-F238E27FC236}">
+                <a16:creationId xmlns:a16="http://schemas.microsoft.com/office/drawing/2014/main" id="{3ECA69A1-7536-43AC-85EF-C7106179F5ED}"/>
+              </a:ext>
+              <a:ext uri="{C183D7F6-B498-43B3-948B-1728B52AA6E4}">
+                <adec:decorative xmlns:adec="http://schemas.microsoft.com/office/drawing/2017/decorative" val="1"/>
+              </a:ext>
+            </a:extLst>
+          </p:cNvPr>
+          <p:cNvSpPr>
+            <a:spLocks noGrp="1" noRot="1" noChangeAspect="1" noMove="1" noResize="1" noEditPoints="1" noAdjustHandles="1" noChangeArrowheads="1" noChangeShapeType="1" noTextEdit="1"/>
+          </p:cNvSpPr>
+          <p:nvPr>
+            <p:extLst>
+              <p:ext uri="{386F3935-93C4-4BCD-93E2-E3B085C9AB24}">
+                <p16:designElem xmlns:p16="http://schemas.microsoft.com/office/powerpoint/2015/main" val="1"/>
+              </p:ext>
+            </p:extLst>
+          </p:nvPr>
+        </p:nvSpPr>
+        <p:spPr>
+          <a:xfrm flipH="1">
+            <a:off x="7604080" y="6453143"/>
+            <a:ext cx="814903" cy="404857"/>
+          </a:xfrm>
+          <a:prstGeom prst="triangle">
+            <a:avLst/>
+          </a:prstGeom>
+          <a:solidFill>
+            <a:schemeClr val="accent1">
+              <a:alpha val="30000"/>
+            </a:schemeClr>
+          </a:solidFill>
+          <a:ln>
+            <a:noFill/>
+          </a:ln>
+        </p:spPr>
+        <p:style>
+          <a:lnRef idx="2">
+            <a:schemeClr val="accent1">
+              <a:shade val="50000"/>
+            </a:schemeClr>
+          </a:lnRef>
+          <a:fillRef idx="1">
+            <a:schemeClr val="accent1"/>
+          </a:fillRef>
+          <a:effectRef idx="0">
+            <a:schemeClr val="accent1"/>
+          </a:effectRef>
+          <a:fontRef idx="minor">
+            <a:schemeClr val="lt1"/>
+          </a:fontRef>
+        </p:style>
+        <p:txBody>
+          <a:bodyPr rtlCol="0" anchor="ctr"/>
+          <a:lstStyle/>
+          <a:p>
+            <a:pPr algn="ctr"/>
+            <a:endParaRPr lang="en-US"/>
+          </a:p>
+        </p:txBody>
+      </p:sp>
+      <p:sp>
+        <p:nvSpPr>
+          <p:cNvPr id="5" name="CuadroTexto 4">
+            <a:extLst>
+              <a:ext uri="{FF2B5EF4-FFF2-40B4-BE49-F238E27FC236}">
+                <a16:creationId xmlns:a16="http://schemas.microsoft.com/office/drawing/2014/main" id="{A2619C58-CA1A-0779-DCDF-63269017A7D0}"/>
+              </a:ext>
+            </a:extLst>
+          </p:cNvPr>
+          <p:cNvSpPr txBox="1"/>
+          <p:nvPr/>
+        </p:nvSpPr>
+        <p:spPr>
+          <a:xfrm>
+            <a:off x="4468218" y="250158"/>
+            <a:ext cx="3255564" cy="369332"/>
+          </a:xfrm>
+          <a:prstGeom prst="rect">
+            <a:avLst/>
+          </a:prstGeom>
+          <a:noFill/>
+          <a:ln w="38100" cap="flat" cmpd="sng" algn="ctr">
+            <a:solidFill>
+              <a:schemeClr val="accent2"/>
+            </a:solidFill>
+            <a:prstDash val="solid"/>
+            <a:round/>
+            <a:headEnd type="none" w="med" len="med"/>
+            <a:tailEnd type="none" w="med" len="med"/>
+          </a:ln>
+        </p:spPr>
+        <p:style>
+          <a:lnRef idx="0">
+            <a:scrgbClr r="0" g="0" b="0"/>
+          </a:lnRef>
+          <a:fillRef idx="0">
+            <a:scrgbClr r="0" g="0" b="0"/>
+          </a:fillRef>
+          <a:effectRef idx="0">
+            <a:scrgbClr r="0" g="0" b="0"/>
+          </a:effectRef>
+          <a:fontRef idx="minor">
+            <a:schemeClr val="accent2"/>
+          </a:fontRef>
+        </p:style>
+        <p:txBody>
+          <a:bodyPr wrap="square" rtlCol="0">
+            <a:spAutoFit/>
+          </a:bodyPr>
+          <a:lstStyle/>
+          <a:p>
+            <a:pPr algn="ctr"/>
+            <a:r>
+              <a:rPr lang="es-CO" b="1" dirty="0"/>
+              <a:t>Gestión de </a:t>
+            </a:r>
+            <a:r>
+              <a:rPr lang="es-CO" b="1" dirty="0" err="1"/>
+              <a:t>Vecimientos</a:t>
+            </a:r>
+            <a:endParaRPr lang="es-CO" b="1" dirty="0"/>
+          </a:p>
+        </p:txBody>
+      </p:sp>
+    </p:spTree>
+    <p:extLst>
+      <p:ext uri="{BB962C8B-B14F-4D97-AF65-F5344CB8AC3E}">
+        <p14:creationId xmlns:p14="http://schemas.microsoft.com/office/powerpoint/2010/main" val="843671556"/>
       </p:ext>
     </p:extLst>
   </p:cSld>

</xml_diff>